<commit_message>
hoan thien bai thuyet trinh
</commit_message>
<xml_diff>
--- a/docs/nhom_15_10123334_10123343_Phan_loai_khoang_gia_dien_thoai.pptx
+++ b/docs/nhom_15_10123334_10123343_Phan_loai_khoang_gia_dien_thoai.pptx
@@ -5,22 +5,22 @@
     <p:sldMasterId id="2147483648" r:id="rId1"/>
   </p:sldMasterIdLst>
   <p:sldIdLst>
-    <p:sldId id="256" r:id="rId7"/>
-    <p:sldId id="257" r:id="rId8"/>
-    <p:sldId id="258" r:id="rId9"/>
-    <p:sldId id="259" r:id="rId10"/>
-    <p:sldId id="260" r:id="rId11"/>
-    <p:sldId id="261" r:id="rId12"/>
-    <p:sldId id="262" r:id="rId13"/>
-    <p:sldId id="263" r:id="rId14"/>
-    <p:sldId id="264" r:id="rId15"/>
-    <p:sldId id="265" r:id="rId16"/>
-    <p:sldId id="266" r:id="rId17"/>
-    <p:sldId id="267" r:id="rId18"/>
-    <p:sldId id="268" r:id="rId19"/>
-    <p:sldId id="269" r:id="rId20"/>
+    <p:sldId id="256" r:id="rId2"/>
+    <p:sldId id="257" r:id="rId3"/>
+    <p:sldId id="258" r:id="rId4"/>
+    <p:sldId id="259" r:id="rId5"/>
+    <p:sldId id="260" r:id="rId6"/>
+    <p:sldId id="261" r:id="rId7"/>
+    <p:sldId id="262" r:id="rId8"/>
+    <p:sldId id="263" r:id="rId9"/>
+    <p:sldId id="264" r:id="rId10"/>
+    <p:sldId id="265" r:id="rId11"/>
+    <p:sldId id="266" r:id="rId12"/>
+    <p:sldId id="267" r:id="rId13"/>
+    <p:sldId id="268" r:id="rId14"/>
+    <p:sldId id="269" r:id="rId15"/>
   </p:sldIdLst>
-  <p:sldSz cx="12191695" cy="6858000" type="screen4x3"/>
+  <p:sldSz cx="12192000" cy="6858000"/>
   <p:notesSz cx="6858000" cy="9144000"/>
   <p:defaultTextStyle>
     <a:defPPr>
@@ -117,6 +117,22 @@
       </a:defRPr>
     </a:lvl9pPr>
   </p:defaultTextStyle>
+  <p:extLst>
+    <p:ext uri="{EFAFB233-063F-42B5-8137-9DF3F51BA10A}">
+      <p15:sldGuideLst xmlns:p15="http://schemas.microsoft.com/office/powerpoint/2012/main">
+        <p15:guide id="1" orient="horz" pos="2160">
+          <p15:clr>
+            <a:srgbClr val="A4A3A4"/>
+          </p15:clr>
+        </p15:guide>
+        <p15:guide id="2" pos="2880">
+          <p15:clr>
+            <a:srgbClr val="A4A3A4"/>
+          </p15:clr>
+        </p15:guide>
+      </p15:sldGuideLst>
+    </p:ext>
+  </p:extLst>
 </p:presentation>
 </file>
 
@@ -158,10 +174,9 @@
           <a:lstStyle/>
           <a:p>
             <a:r>
-              <a:rPr lang="en-US" smtClean="0"/>
+              <a:rPr lang="en-US"/>
               <a:t>Click to edit Master title style</a:t>
             </a:r>
-            <a:endParaRPr lang="en-US"/>
           </a:p>
         </p:txBody>
       </p:sp>
@@ -277,10 +292,9 @@
           </a:lstStyle>
           <a:p>
             <a:r>
-              <a:rPr lang="en-US" smtClean="0"/>
+              <a:rPr lang="en-US"/>
               <a:t>Click to edit Master subtitle style</a:t>
             </a:r>
-            <a:endParaRPr lang="en-US"/>
           </a:p>
         </p:txBody>
       </p:sp>
@@ -301,7 +315,7 @@
           <a:p>
             <a:fld id="{5BCAD085-E8A6-8845-BD4E-CB4CCA059FC4}" type="datetimeFigureOut">
               <a:rPr lang="en-US" smtClean="0"/>
-              <a:t>1/27/13</a:t>
+              <a:t>9/27/2026</a:t>
             </a:fld>
             <a:endParaRPr lang="en-US"/>
           </a:p>
@@ -395,10 +409,9 @@
           <a:lstStyle/>
           <a:p>
             <a:r>
-              <a:rPr lang="en-US" smtClean="0"/>
+              <a:rPr lang="en-US"/>
               <a:t>Click to edit Master title style</a:t>
             </a:r>
-            <a:endParaRPr lang="en-US"/>
           </a:p>
         </p:txBody>
       </p:sp>
@@ -419,38 +432,37 @@
           <a:p>
             <a:pPr lvl="0"/>
             <a:r>
-              <a:rPr lang="en-US" smtClean="0"/>
+              <a:rPr lang="en-US"/>
               <a:t>Click to edit Master text styles</a:t>
             </a:r>
           </a:p>
           <a:p>
             <a:pPr lvl="1"/>
             <a:r>
-              <a:rPr lang="en-US" smtClean="0"/>
+              <a:rPr lang="en-US"/>
               <a:t>Second level</a:t>
             </a:r>
           </a:p>
           <a:p>
             <a:pPr lvl="2"/>
             <a:r>
-              <a:rPr lang="en-US" smtClean="0"/>
+              <a:rPr lang="en-US"/>
               <a:t>Third level</a:t>
             </a:r>
           </a:p>
           <a:p>
             <a:pPr lvl="3"/>
             <a:r>
-              <a:rPr lang="en-US" smtClean="0"/>
+              <a:rPr lang="en-US"/>
               <a:t>Fourth level</a:t>
             </a:r>
           </a:p>
           <a:p>
             <a:pPr lvl="4"/>
             <a:r>
-              <a:rPr lang="en-US" smtClean="0"/>
+              <a:rPr lang="en-US"/>
               <a:t>Fifth level</a:t>
             </a:r>
-            <a:endParaRPr lang="en-US"/>
           </a:p>
         </p:txBody>
       </p:sp>
@@ -471,7 +483,7 @@
           <a:p>
             <a:fld id="{5BCAD085-E8A6-8845-BD4E-CB4CCA059FC4}" type="datetimeFigureOut">
               <a:rPr lang="en-US" smtClean="0"/>
-              <a:t>1/27/13</a:t>
+              <a:t>9/27/2026</a:t>
             </a:fld>
             <a:endParaRPr lang="en-US"/>
           </a:p>
@@ -570,10 +582,9 @@
           <a:lstStyle/>
           <a:p>
             <a:r>
-              <a:rPr lang="en-US" smtClean="0"/>
+              <a:rPr lang="en-US"/>
               <a:t>Click to edit Master title style</a:t>
             </a:r>
-            <a:endParaRPr lang="en-US"/>
           </a:p>
         </p:txBody>
       </p:sp>
@@ -599,38 +610,37 @@
           <a:p>
             <a:pPr lvl="0"/>
             <a:r>
-              <a:rPr lang="en-US" smtClean="0"/>
+              <a:rPr lang="en-US"/>
               <a:t>Click to edit Master text styles</a:t>
             </a:r>
           </a:p>
           <a:p>
             <a:pPr lvl="1"/>
             <a:r>
-              <a:rPr lang="en-US" smtClean="0"/>
+              <a:rPr lang="en-US"/>
               <a:t>Second level</a:t>
             </a:r>
           </a:p>
           <a:p>
             <a:pPr lvl="2"/>
             <a:r>
-              <a:rPr lang="en-US" smtClean="0"/>
+              <a:rPr lang="en-US"/>
               <a:t>Third level</a:t>
             </a:r>
           </a:p>
           <a:p>
             <a:pPr lvl="3"/>
             <a:r>
-              <a:rPr lang="en-US" smtClean="0"/>
+              <a:rPr lang="en-US"/>
               <a:t>Fourth level</a:t>
             </a:r>
           </a:p>
           <a:p>
             <a:pPr lvl="4"/>
             <a:r>
-              <a:rPr lang="en-US" smtClean="0"/>
+              <a:rPr lang="en-US"/>
               <a:t>Fifth level</a:t>
             </a:r>
-            <a:endParaRPr lang="en-US"/>
           </a:p>
         </p:txBody>
       </p:sp>
@@ -651,7 +661,7 @@
           <a:p>
             <a:fld id="{5BCAD085-E8A6-8845-BD4E-CB4CCA059FC4}" type="datetimeFigureOut">
               <a:rPr lang="en-US" smtClean="0"/>
-              <a:t>1/27/13</a:t>
+              <a:t>9/27/2026</a:t>
             </a:fld>
             <a:endParaRPr lang="en-US"/>
           </a:p>
@@ -745,10 +755,9 @@
           <a:lstStyle/>
           <a:p>
             <a:r>
-              <a:rPr lang="en-US" smtClean="0"/>
+              <a:rPr lang="en-US"/>
               <a:t>Click to edit Master title style</a:t>
             </a:r>
-            <a:endParaRPr lang="en-US"/>
           </a:p>
         </p:txBody>
       </p:sp>
@@ -769,38 +778,37 @@
           <a:p>
             <a:pPr lvl="0"/>
             <a:r>
-              <a:rPr lang="en-US" smtClean="0"/>
+              <a:rPr lang="en-US"/>
               <a:t>Click to edit Master text styles</a:t>
             </a:r>
           </a:p>
           <a:p>
             <a:pPr lvl="1"/>
             <a:r>
-              <a:rPr lang="en-US" smtClean="0"/>
+              <a:rPr lang="en-US"/>
               <a:t>Second level</a:t>
             </a:r>
           </a:p>
           <a:p>
             <a:pPr lvl="2"/>
             <a:r>
-              <a:rPr lang="en-US" smtClean="0"/>
+              <a:rPr lang="en-US"/>
               <a:t>Third level</a:t>
             </a:r>
           </a:p>
           <a:p>
             <a:pPr lvl="3"/>
             <a:r>
-              <a:rPr lang="en-US" smtClean="0"/>
+              <a:rPr lang="en-US"/>
               <a:t>Fourth level</a:t>
             </a:r>
           </a:p>
           <a:p>
             <a:pPr lvl="4"/>
             <a:r>
-              <a:rPr lang="en-US" smtClean="0"/>
+              <a:rPr lang="en-US"/>
               <a:t>Fifth level</a:t>
             </a:r>
-            <a:endParaRPr lang="en-US"/>
           </a:p>
         </p:txBody>
       </p:sp>
@@ -821,7 +829,7 @@
           <a:p>
             <a:fld id="{5BCAD085-E8A6-8845-BD4E-CB4CCA059FC4}" type="datetimeFigureOut">
               <a:rPr lang="en-US" smtClean="0"/>
-              <a:t>1/27/13</a:t>
+              <a:t>9/27/2026</a:t>
             </a:fld>
             <a:endParaRPr lang="en-US"/>
           </a:p>
@@ -924,10 +932,9 @@
           </a:lstStyle>
           <a:p>
             <a:r>
-              <a:rPr lang="en-US" smtClean="0"/>
+              <a:rPr lang="en-US"/>
               <a:t>Click to edit Master title style</a:t>
             </a:r>
-            <a:endParaRPr lang="en-US"/>
           </a:p>
         </p:txBody>
       </p:sp>
@@ -1044,7 +1051,7 @@
           <a:p>
             <a:pPr lvl="0"/>
             <a:r>
-              <a:rPr lang="en-US" smtClean="0"/>
+              <a:rPr lang="en-US"/>
               <a:t>Click to edit Master text styles</a:t>
             </a:r>
           </a:p>
@@ -1067,7 +1074,7 @@
           <a:p>
             <a:fld id="{5BCAD085-E8A6-8845-BD4E-CB4CCA059FC4}" type="datetimeFigureOut">
               <a:rPr lang="en-US" smtClean="0"/>
-              <a:t>1/27/13</a:t>
+              <a:t>9/27/2026</a:t>
             </a:fld>
             <a:endParaRPr lang="en-US"/>
           </a:p>
@@ -1161,10 +1168,9 @@
           <a:lstStyle/>
           <a:p>
             <a:r>
-              <a:rPr lang="en-US" smtClean="0"/>
+              <a:rPr lang="en-US"/>
               <a:t>Click to edit Master title style</a:t>
             </a:r>
-            <a:endParaRPr lang="en-US"/>
           </a:p>
         </p:txBody>
       </p:sp>
@@ -1218,38 +1224,37 @@
           <a:p>
             <a:pPr lvl="0"/>
             <a:r>
-              <a:rPr lang="en-US" smtClean="0"/>
+              <a:rPr lang="en-US"/>
               <a:t>Click to edit Master text styles</a:t>
             </a:r>
           </a:p>
           <a:p>
             <a:pPr lvl="1"/>
             <a:r>
-              <a:rPr lang="en-US" smtClean="0"/>
+              <a:rPr lang="en-US"/>
               <a:t>Second level</a:t>
             </a:r>
           </a:p>
           <a:p>
             <a:pPr lvl="2"/>
             <a:r>
-              <a:rPr lang="en-US" smtClean="0"/>
+              <a:rPr lang="en-US"/>
               <a:t>Third level</a:t>
             </a:r>
           </a:p>
           <a:p>
             <a:pPr lvl="3"/>
             <a:r>
-              <a:rPr lang="en-US" smtClean="0"/>
+              <a:rPr lang="en-US"/>
               <a:t>Fourth level</a:t>
             </a:r>
           </a:p>
           <a:p>
             <a:pPr lvl="4"/>
             <a:r>
-              <a:rPr lang="en-US" smtClean="0"/>
+              <a:rPr lang="en-US"/>
               <a:t>Fifth level</a:t>
             </a:r>
-            <a:endParaRPr lang="en-US"/>
           </a:p>
         </p:txBody>
       </p:sp>
@@ -1303,38 +1308,37 @@
           <a:p>
             <a:pPr lvl="0"/>
             <a:r>
-              <a:rPr lang="en-US" smtClean="0"/>
+              <a:rPr lang="en-US"/>
               <a:t>Click to edit Master text styles</a:t>
             </a:r>
           </a:p>
           <a:p>
             <a:pPr lvl="1"/>
             <a:r>
-              <a:rPr lang="en-US" smtClean="0"/>
+              <a:rPr lang="en-US"/>
               <a:t>Second level</a:t>
             </a:r>
           </a:p>
           <a:p>
             <a:pPr lvl="2"/>
             <a:r>
-              <a:rPr lang="en-US" smtClean="0"/>
+              <a:rPr lang="en-US"/>
               <a:t>Third level</a:t>
             </a:r>
           </a:p>
           <a:p>
             <a:pPr lvl="3"/>
             <a:r>
-              <a:rPr lang="en-US" smtClean="0"/>
+              <a:rPr lang="en-US"/>
               <a:t>Fourth level</a:t>
             </a:r>
           </a:p>
           <a:p>
             <a:pPr lvl="4"/>
             <a:r>
-              <a:rPr lang="en-US" smtClean="0"/>
+              <a:rPr lang="en-US"/>
               <a:t>Fifth level</a:t>
             </a:r>
-            <a:endParaRPr lang="en-US"/>
           </a:p>
         </p:txBody>
       </p:sp>
@@ -1355,7 +1359,7 @@
           <a:p>
             <a:fld id="{5BCAD085-E8A6-8845-BD4E-CB4CCA059FC4}" type="datetimeFigureOut">
               <a:rPr lang="en-US" smtClean="0"/>
-              <a:t>1/27/13</a:t>
+              <a:t>9/27/2026</a:t>
             </a:fld>
             <a:endParaRPr lang="en-US"/>
           </a:p>
@@ -1453,10 +1457,9 @@
           </a:lstStyle>
           <a:p>
             <a:r>
-              <a:rPr lang="en-US" smtClean="0"/>
+              <a:rPr lang="en-US"/>
               <a:t>Click to edit Master title style</a:t>
             </a:r>
-            <a:endParaRPr lang="en-US"/>
           </a:p>
         </p:txBody>
       </p:sp>
@@ -1519,7 +1522,7 @@
           <a:p>
             <a:pPr lvl="0"/>
             <a:r>
-              <a:rPr lang="en-US" smtClean="0"/>
+              <a:rPr lang="en-US"/>
               <a:t>Click to edit Master text styles</a:t>
             </a:r>
           </a:p>
@@ -1575,38 +1578,37 @@
           <a:p>
             <a:pPr lvl="0"/>
             <a:r>
-              <a:rPr lang="en-US" smtClean="0"/>
+              <a:rPr lang="en-US"/>
               <a:t>Click to edit Master text styles</a:t>
             </a:r>
           </a:p>
           <a:p>
             <a:pPr lvl="1"/>
             <a:r>
-              <a:rPr lang="en-US" smtClean="0"/>
+              <a:rPr lang="en-US"/>
               <a:t>Second level</a:t>
             </a:r>
           </a:p>
           <a:p>
             <a:pPr lvl="2"/>
             <a:r>
-              <a:rPr lang="en-US" smtClean="0"/>
+              <a:rPr lang="en-US"/>
               <a:t>Third level</a:t>
             </a:r>
           </a:p>
           <a:p>
             <a:pPr lvl="3"/>
             <a:r>
-              <a:rPr lang="en-US" smtClean="0"/>
+              <a:rPr lang="en-US"/>
               <a:t>Fourth level</a:t>
             </a:r>
           </a:p>
           <a:p>
             <a:pPr lvl="4"/>
             <a:r>
-              <a:rPr lang="en-US" smtClean="0"/>
+              <a:rPr lang="en-US"/>
               <a:t>Fifth level</a:t>
             </a:r>
-            <a:endParaRPr lang="en-US"/>
           </a:p>
         </p:txBody>
       </p:sp>
@@ -1669,7 +1671,7 @@
           <a:p>
             <a:pPr lvl="0"/>
             <a:r>
-              <a:rPr lang="en-US" smtClean="0"/>
+              <a:rPr lang="en-US"/>
               <a:t>Click to edit Master text styles</a:t>
             </a:r>
           </a:p>
@@ -1725,38 +1727,37 @@
           <a:p>
             <a:pPr lvl="0"/>
             <a:r>
-              <a:rPr lang="en-US" smtClean="0"/>
+              <a:rPr lang="en-US"/>
               <a:t>Click to edit Master text styles</a:t>
             </a:r>
           </a:p>
           <a:p>
             <a:pPr lvl="1"/>
             <a:r>
-              <a:rPr lang="en-US" smtClean="0"/>
+              <a:rPr lang="en-US"/>
               <a:t>Second level</a:t>
             </a:r>
           </a:p>
           <a:p>
             <a:pPr lvl="2"/>
             <a:r>
-              <a:rPr lang="en-US" smtClean="0"/>
+              <a:rPr lang="en-US"/>
               <a:t>Third level</a:t>
             </a:r>
           </a:p>
           <a:p>
             <a:pPr lvl="3"/>
             <a:r>
-              <a:rPr lang="en-US" smtClean="0"/>
+              <a:rPr lang="en-US"/>
               <a:t>Fourth level</a:t>
             </a:r>
           </a:p>
           <a:p>
             <a:pPr lvl="4"/>
             <a:r>
-              <a:rPr lang="en-US" smtClean="0"/>
+              <a:rPr lang="en-US"/>
               <a:t>Fifth level</a:t>
             </a:r>
-            <a:endParaRPr lang="en-US"/>
           </a:p>
         </p:txBody>
       </p:sp>
@@ -1777,7 +1778,7 @@
           <a:p>
             <a:fld id="{5BCAD085-E8A6-8845-BD4E-CB4CCA059FC4}" type="datetimeFigureOut">
               <a:rPr lang="en-US" smtClean="0"/>
-              <a:t>1/27/13</a:t>
+              <a:t>9/27/2026</a:t>
             </a:fld>
             <a:endParaRPr lang="en-US"/>
           </a:p>
@@ -1871,10 +1872,9 @@
           <a:lstStyle/>
           <a:p>
             <a:r>
-              <a:rPr lang="en-US" smtClean="0"/>
+              <a:rPr lang="en-US"/>
               <a:t>Click to edit Master title style</a:t>
             </a:r>
-            <a:endParaRPr lang="en-US"/>
           </a:p>
         </p:txBody>
       </p:sp>
@@ -1895,7 +1895,7 @@
           <a:p>
             <a:fld id="{5BCAD085-E8A6-8845-BD4E-CB4CCA059FC4}" type="datetimeFigureOut">
               <a:rPr lang="en-US" smtClean="0"/>
-              <a:t>1/27/13</a:t>
+              <a:t>9/27/2026</a:t>
             </a:fld>
             <a:endParaRPr lang="en-US"/>
           </a:p>
@@ -1990,7 +1990,7 @@
           <a:p>
             <a:fld id="{5BCAD085-E8A6-8845-BD4E-CB4CCA059FC4}" type="datetimeFigureOut">
               <a:rPr lang="en-US" smtClean="0"/>
-              <a:t>1/27/13</a:t>
+              <a:t>9/27/2026</a:t>
             </a:fld>
             <a:endParaRPr lang="en-US"/>
           </a:p>
@@ -2093,10 +2093,9 @@
           </a:lstStyle>
           <a:p>
             <a:r>
-              <a:rPr lang="en-US" smtClean="0"/>
+              <a:rPr lang="en-US"/>
               <a:t>Click to edit Master title style</a:t>
             </a:r>
-            <a:endParaRPr lang="en-US"/>
           </a:p>
         </p:txBody>
       </p:sp>
@@ -2150,38 +2149,37 @@
           <a:p>
             <a:pPr lvl="0"/>
             <a:r>
-              <a:rPr lang="en-US" smtClean="0"/>
+              <a:rPr lang="en-US"/>
               <a:t>Click to edit Master text styles</a:t>
             </a:r>
           </a:p>
           <a:p>
             <a:pPr lvl="1"/>
             <a:r>
-              <a:rPr lang="en-US" smtClean="0"/>
+              <a:rPr lang="en-US"/>
               <a:t>Second level</a:t>
             </a:r>
           </a:p>
           <a:p>
             <a:pPr lvl="2"/>
             <a:r>
-              <a:rPr lang="en-US" smtClean="0"/>
+              <a:rPr lang="en-US"/>
               <a:t>Third level</a:t>
             </a:r>
           </a:p>
           <a:p>
             <a:pPr lvl="3"/>
             <a:r>
-              <a:rPr lang="en-US" smtClean="0"/>
+              <a:rPr lang="en-US"/>
               <a:t>Fourth level</a:t>
             </a:r>
           </a:p>
           <a:p>
             <a:pPr lvl="4"/>
             <a:r>
-              <a:rPr lang="en-US" smtClean="0"/>
+              <a:rPr lang="en-US"/>
               <a:t>Fifth level</a:t>
             </a:r>
-            <a:endParaRPr lang="en-US"/>
           </a:p>
         </p:txBody>
       </p:sp>
@@ -2244,7 +2242,7 @@
           <a:p>
             <a:pPr lvl="0"/>
             <a:r>
-              <a:rPr lang="en-US" smtClean="0"/>
+              <a:rPr lang="en-US"/>
               <a:t>Click to edit Master text styles</a:t>
             </a:r>
           </a:p>
@@ -2267,7 +2265,7 @@
           <a:p>
             <a:fld id="{5BCAD085-E8A6-8845-BD4E-CB4CCA059FC4}" type="datetimeFigureOut">
               <a:rPr lang="en-US" smtClean="0"/>
-              <a:t>1/27/13</a:t>
+              <a:t>9/27/2026</a:t>
             </a:fld>
             <a:endParaRPr lang="en-US"/>
           </a:p>
@@ -2370,10 +2368,9 @@
           </a:lstStyle>
           <a:p>
             <a:r>
-              <a:rPr lang="en-US" smtClean="0"/>
+              <a:rPr lang="en-US"/>
               <a:t>Click to edit Master title style</a:t>
             </a:r>
-            <a:endParaRPr lang="en-US"/>
           </a:p>
         </p:txBody>
       </p:sp>
@@ -2497,7 +2494,7 @@
           <a:p>
             <a:pPr lvl="0"/>
             <a:r>
-              <a:rPr lang="en-US" smtClean="0"/>
+              <a:rPr lang="en-US"/>
               <a:t>Click to edit Master text styles</a:t>
             </a:r>
           </a:p>
@@ -2520,7 +2517,7 @@
           <a:p>
             <a:fld id="{5BCAD085-E8A6-8845-BD4E-CB4CCA059FC4}" type="datetimeFigureOut">
               <a:rPr lang="en-US" smtClean="0"/>
-              <a:t>1/27/13</a:t>
+              <a:t>9/27/2026</a:t>
             </a:fld>
             <a:endParaRPr lang="en-US"/>
           </a:p>
@@ -2629,10 +2626,9 @@
           <a:lstStyle/>
           <a:p>
             <a:r>
-              <a:rPr lang="en-US" smtClean="0"/>
+              <a:rPr lang="en-US"/>
               <a:t>Click to edit Master title style</a:t>
             </a:r>
-            <a:endParaRPr lang="en-US"/>
           </a:p>
         </p:txBody>
       </p:sp>
@@ -2663,38 +2659,37 @@
           <a:p>
             <a:pPr lvl="0"/>
             <a:r>
-              <a:rPr lang="en-US" smtClean="0"/>
+              <a:rPr lang="en-US"/>
               <a:t>Click to edit Master text styles</a:t>
             </a:r>
           </a:p>
           <a:p>
             <a:pPr lvl="1"/>
             <a:r>
-              <a:rPr lang="en-US" smtClean="0"/>
+              <a:rPr lang="en-US"/>
               <a:t>Second level</a:t>
             </a:r>
           </a:p>
           <a:p>
             <a:pPr lvl="2"/>
             <a:r>
-              <a:rPr lang="en-US" smtClean="0"/>
+              <a:rPr lang="en-US"/>
               <a:t>Third level</a:t>
             </a:r>
           </a:p>
           <a:p>
             <a:pPr lvl="3"/>
             <a:r>
-              <a:rPr lang="en-US" smtClean="0"/>
+              <a:rPr lang="en-US"/>
               <a:t>Fourth level</a:t>
             </a:r>
           </a:p>
           <a:p>
             <a:pPr lvl="4"/>
             <a:r>
-              <a:rPr lang="en-US" smtClean="0"/>
+              <a:rPr lang="en-US"/>
               <a:t>Fifth level</a:t>
             </a:r>
-            <a:endParaRPr lang="en-US"/>
           </a:p>
         </p:txBody>
       </p:sp>
@@ -2733,7 +2728,7 @@
           <a:p>
             <a:fld id="{5BCAD085-E8A6-8845-BD4E-CB4CCA059FC4}" type="datetimeFigureOut">
               <a:rPr lang="en-US" smtClean="0"/>
-              <a:t>1/27/13</a:t>
+              <a:t>9/27/2026</a:t>
             </a:fld>
             <a:endParaRPr lang="en-US"/>
           </a:p>
@@ -3092,7 +3087,7 @@
 </file>
 
 <file path=ppt/slides/slide1.xml><?xml version="1.0" encoding="utf-8"?>
-<p:sld xmlns:a="http://schemas.openxmlformats.org/drawingml/2006/main" xmlns:p="http://schemas.openxmlformats.org/presentationml/2006/main" xmlns:r="http://schemas.openxmlformats.org/officeDocument/2006/relationships">
+<p:sld xmlns:a="http://schemas.openxmlformats.org/drawingml/2006/main" xmlns:r="http://schemas.openxmlformats.org/officeDocument/2006/relationships" xmlns:p="http://schemas.openxmlformats.org/presentationml/2006/main">
   <p:cSld>
     <p:spTree>
       <p:nvGrpSpPr>
@@ -3100,7 +3095,14 @@
         <p:cNvGrpSpPr/>
         <p:nvPr/>
       </p:nvGrpSpPr>
-      <p:grpSpPr/>
+      <p:grpSpPr>
+        <a:xfrm>
+          <a:off x="0" y="0"/>
+          <a:ext cx="0" cy="0"/>
+          <a:chOff x="0" y="0"/>
+          <a:chExt cx="0" cy="0"/>
+        </a:xfrm>
+      </p:grpSpPr>
       <p:sp>
         <p:nvSpPr>
           <p:cNvPr id="2" name="Rectangle 1"/>
@@ -3141,6 +3143,7 @@
           <a:lstStyle/>
           <a:p>
             <a:pPr algn="ctr"/>
+            <a:endParaRPr/>
           </a:p>
         </p:txBody>
       </p:sp>
@@ -3186,6 +3189,7 @@
           <a:lstStyle/>
           <a:p>
             <a:pPr algn="ctr"/>
+            <a:endParaRPr/>
           </a:p>
         </p:txBody>
       </p:sp>
@@ -3314,7 +3318,9 @@
             <a:spAutoFit/>
           </a:bodyPr>
           <a:lstStyle/>
-          <a:p/>
+          <a:p>
+            <a:endParaRPr/>
+          </a:p>
           <a:p>
             <a:pPr>
               <a:spcBef>
@@ -3322,7 +3328,7 @@
               </a:spcBef>
             </a:pPr>
             <a:r>
-              <a:rPr b="1" sz="1300">
+              <a:rPr sz="1300" b="1">
                 <a:solidFill>
                   <a:srgbClr val="1B365D"/>
                 </a:solidFill>
@@ -3345,7 +3351,7 @@
               </a:spcBef>
             </a:pPr>
             <a:r>
-              <a:rPr b="1" sz="1300">
+              <a:rPr sz="1300" b="1">
                 <a:solidFill>
                   <a:srgbClr val="1B365D"/>
                 </a:solidFill>
@@ -3368,7 +3374,7 @@
               </a:spcBef>
             </a:pPr>
             <a:r>
-              <a:rPr b="1" sz="1300">
+              <a:rPr sz="1300" b="1">
                 <a:solidFill>
                   <a:srgbClr val="1B365D"/>
                 </a:solidFill>
@@ -3391,7 +3397,7 @@
               </a:spcBef>
             </a:pPr>
             <a:r>
-              <a:rPr b="1" sz="1300">
+              <a:rPr sz="1300" b="1">
                 <a:solidFill>
                   <a:srgbClr val="1B365D"/>
                 </a:solidFill>
@@ -3418,7 +3424,7 @@
 </file>
 
 <file path=ppt/slides/slide10.xml><?xml version="1.0" encoding="utf-8"?>
-<p:sld xmlns:a="http://schemas.openxmlformats.org/drawingml/2006/main" xmlns:p="http://schemas.openxmlformats.org/presentationml/2006/main" xmlns:r="http://schemas.openxmlformats.org/officeDocument/2006/relationships">
+<p:sld xmlns:a="http://schemas.openxmlformats.org/drawingml/2006/main" xmlns:r="http://schemas.openxmlformats.org/officeDocument/2006/relationships" xmlns:p="http://schemas.openxmlformats.org/presentationml/2006/main">
   <p:cSld>
     <p:spTree>
       <p:nvGrpSpPr>
@@ -3426,7 +3432,14 @@
         <p:cNvGrpSpPr/>
         <p:nvPr/>
       </p:nvGrpSpPr>
-      <p:grpSpPr/>
+      <p:grpSpPr>
+        <a:xfrm>
+          <a:off x="0" y="0"/>
+          <a:ext cx="0" cy="0"/>
+          <a:chOff x="0" y="0"/>
+          <a:chExt cx="0" cy="0"/>
+        </a:xfrm>
+      </p:grpSpPr>
       <p:sp>
         <p:nvSpPr>
           <p:cNvPr id="2" name="TextBox 1"/>
@@ -3539,6 +3552,7 @@
           <a:lstStyle/>
           <a:p>
             <a:pPr algn="ctr"/>
+            <a:endParaRPr/>
           </a:p>
         </p:txBody>
       </p:sp>
@@ -3584,6 +3598,7 @@
           <a:lstStyle/>
           <a:p>
             <a:pPr algn="ctr"/>
+            <a:endParaRPr/>
           </a:p>
         </p:txBody>
       </p:sp>
@@ -3610,7 +3625,7 @@
           <a:lstStyle/>
           <a:p>
             <a:pPr>
-              <a:defRPr b="1" sz="1200">
+              <a:defRPr sz="1200" b="1">
                 <a:solidFill>
                   <a:srgbClr val="1B365D"/>
                 </a:solidFill>
@@ -3740,6 +3755,7 @@
           <a:lstStyle/>
           <a:p>
             <a:pPr algn="ctr"/>
+            <a:endParaRPr/>
           </a:p>
         </p:txBody>
       </p:sp>
@@ -3766,7 +3782,7 @@
           <a:lstStyle/>
           <a:p>
             <a:pPr>
-              <a:defRPr b="1" sz="1200">
+              <a:defRPr sz="1200" b="1">
                 <a:solidFill>
                   <a:srgbClr val="1B365D"/>
                 </a:solidFill>
@@ -3783,7 +3799,7 @@
               </a:spcBef>
             </a:pPr>
             <a:r>
-              <a:rPr b="1" sz="1100">
+              <a:rPr sz="1100" b="1">
                 <a:solidFill>
                   <a:srgbClr val="007AFF"/>
                 </a:solidFill>
@@ -3807,7 +3823,7 @@
               </a:spcBef>
             </a:pPr>
             <a:r>
-              <a:rPr b="1" sz="1100">
+              <a:rPr sz="1100" b="1">
                 <a:solidFill>
                   <a:srgbClr val="007AFF"/>
                 </a:solidFill>
@@ -3831,7 +3847,7 @@
               </a:spcBef>
             </a:pPr>
             <a:r>
-              <a:rPr b="1" sz="1100">
+              <a:rPr sz="1100" b="1">
                 <a:solidFill>
                   <a:srgbClr val="007AFF"/>
                 </a:solidFill>
@@ -3855,7 +3871,7 @@
               </a:spcBef>
             </a:pPr>
             <a:r>
-              <a:rPr b="1" sz="1100">
+              <a:rPr sz="1100" b="1">
                 <a:solidFill>
                   <a:srgbClr val="007AFF"/>
                 </a:solidFill>
@@ -3885,7 +3901,7 @@
 </file>
 
 <file path=ppt/slides/slide11.xml><?xml version="1.0" encoding="utf-8"?>
-<p:sld xmlns:a="http://schemas.openxmlformats.org/drawingml/2006/main" xmlns:p="http://schemas.openxmlformats.org/presentationml/2006/main" xmlns:r="http://schemas.openxmlformats.org/officeDocument/2006/relationships">
+<p:sld xmlns:a="http://schemas.openxmlformats.org/drawingml/2006/main" xmlns:r="http://schemas.openxmlformats.org/officeDocument/2006/relationships" xmlns:p="http://schemas.openxmlformats.org/presentationml/2006/main">
   <p:cSld>
     <p:spTree>
       <p:nvGrpSpPr>
@@ -3893,7 +3909,14 @@
         <p:cNvGrpSpPr/>
         <p:nvPr/>
       </p:nvGrpSpPr>
-      <p:grpSpPr/>
+      <p:grpSpPr>
+        <a:xfrm>
+          <a:off x="0" y="0"/>
+          <a:ext cx="0" cy="0"/>
+          <a:chOff x="0" y="0"/>
+          <a:chExt cx="0" cy="0"/>
+        </a:xfrm>
+      </p:grpSpPr>
       <p:sp>
         <p:nvSpPr>
           <p:cNvPr id="2" name="TextBox 1"/>
@@ -4006,6 +4029,7 @@
           <a:lstStyle/>
           <a:p>
             <a:pPr algn="ctr"/>
+            <a:endParaRPr/>
           </a:p>
         </p:txBody>
       </p:sp>
@@ -4051,6 +4075,7 @@
           <a:lstStyle/>
           <a:p>
             <a:pPr algn="ctr"/>
+            <a:endParaRPr/>
           </a:p>
         </p:txBody>
       </p:sp>
@@ -4077,7 +4102,7 @@
           <a:lstStyle/>
           <a:p>
             <a:pPr>
-              <a:defRPr b="1" sz="1200">
+              <a:defRPr sz="1200" b="1">
                 <a:solidFill>
                   <a:srgbClr val="1B365D"/>
                 </a:solidFill>
@@ -4094,7 +4119,7 @@
               </a:spcBef>
             </a:pPr>
             <a:r>
-              <a:rPr b="1" sz="1100">
+              <a:rPr sz="1100" b="1">
                 <a:solidFill>
                   <a:srgbClr val="10B981"/>
                 </a:solidFill>
@@ -4122,7 +4147,7 @@
               </a:spcBef>
             </a:pPr>
             <a:r>
-              <a:rPr b="1" sz="1100">
+              <a:rPr sz="1100" b="1">
                 <a:solidFill>
                   <a:srgbClr val="10B981"/>
                 </a:solidFill>
@@ -4185,6 +4210,7 @@
           <a:lstStyle/>
           <a:p>
             <a:pPr algn="ctr"/>
+            <a:endParaRPr/>
           </a:p>
         </p:txBody>
       </p:sp>
@@ -4211,7 +4237,7 @@
           <a:lstStyle/>
           <a:p>
             <a:pPr>
-              <a:defRPr b="1" sz="1200">
+              <a:defRPr sz="1200" b="1">
                 <a:solidFill>
                   <a:srgbClr val="1B365D"/>
                 </a:solidFill>
@@ -4228,7 +4254,7 @@
               </a:spcBef>
             </a:pPr>
             <a:r>
-              <a:rPr b="1" sz="1100">
+              <a:rPr sz="1100" b="1">
                 <a:solidFill>
                   <a:srgbClr val="007AFF"/>
                 </a:solidFill>
@@ -4254,7 +4280,7 @@
               </a:spcBef>
             </a:pPr>
             <a:r>
-              <a:rPr b="1" sz="1100">
+              <a:rPr sz="1100" b="1">
                 <a:solidFill>
                   <a:srgbClr val="007AFF"/>
                 </a:solidFill>
@@ -4280,7 +4306,7 @@
               </a:spcBef>
             </a:pPr>
             <a:r>
-              <a:rPr b="1" sz="1100">
+              <a:rPr sz="1100" b="1">
                 <a:solidFill>
                   <a:srgbClr val="007AFF"/>
                 </a:solidFill>
@@ -4309,7 +4335,7 @@
 </file>
 
 <file path=ppt/slides/slide12.xml><?xml version="1.0" encoding="utf-8"?>
-<p:sld xmlns:a="http://schemas.openxmlformats.org/drawingml/2006/main" xmlns:p="http://schemas.openxmlformats.org/presentationml/2006/main" xmlns:r="http://schemas.openxmlformats.org/officeDocument/2006/relationships">
+<p:sld xmlns:a="http://schemas.openxmlformats.org/drawingml/2006/main" xmlns:r="http://schemas.openxmlformats.org/officeDocument/2006/relationships" xmlns:p="http://schemas.openxmlformats.org/presentationml/2006/main">
   <p:cSld>
     <p:spTree>
       <p:nvGrpSpPr>
@@ -4317,7 +4343,14 @@
         <p:cNvGrpSpPr/>
         <p:nvPr/>
       </p:nvGrpSpPr>
-      <p:grpSpPr/>
+      <p:grpSpPr>
+        <a:xfrm>
+          <a:off x="0" y="0"/>
+          <a:ext cx="0" cy="0"/>
+          <a:chOff x="0" y="0"/>
+          <a:chExt cx="0" cy="0"/>
+        </a:xfrm>
+      </p:grpSpPr>
       <p:sp>
         <p:nvSpPr>
           <p:cNvPr id="2" name="TextBox 1"/>
@@ -4430,6 +4463,7 @@
           <a:lstStyle/>
           <a:p>
             <a:pPr algn="ctr"/>
+            <a:endParaRPr/>
           </a:p>
         </p:txBody>
       </p:sp>
@@ -4475,6 +4509,7 @@
           <a:lstStyle/>
           <a:p>
             <a:pPr algn="ctr"/>
+            <a:endParaRPr/>
           </a:p>
         </p:txBody>
       </p:sp>
@@ -4501,7 +4536,7 @@
           <a:lstStyle/>
           <a:p>
             <a:pPr>
-              <a:defRPr b="1" sz="1200">
+              <a:defRPr sz="1200" b="1">
                 <a:solidFill>
                   <a:srgbClr val="1B365D"/>
                 </a:solidFill>
@@ -4582,6 +4617,7 @@
           <a:lstStyle/>
           <a:p>
             <a:pPr algn="ctr"/>
+            <a:endParaRPr/>
           </a:p>
         </p:txBody>
       </p:sp>
@@ -4608,7 +4644,7 @@
           <a:lstStyle/>
           <a:p>
             <a:pPr>
-              <a:defRPr b="1" sz="1200">
+              <a:defRPr sz="1200" b="1">
                 <a:solidFill>
                   <a:srgbClr val="1B365D"/>
                 </a:solidFill>
@@ -4681,6 +4717,7 @@
           <a:lstStyle/>
           <a:p>
             <a:pPr algn="ctr"/>
+            <a:endParaRPr/>
           </a:p>
         </p:txBody>
       </p:sp>
@@ -4707,7 +4744,7 @@
           <a:lstStyle/>
           <a:p>
             <a:pPr>
-              <a:defRPr b="1" sz="1200">
+              <a:defRPr sz="1200" b="1">
                 <a:solidFill>
                   <a:srgbClr val="1B365D"/>
                 </a:solidFill>
@@ -4751,7 +4788,7 @@
 </file>
 
 <file path=ppt/slides/slide13.xml><?xml version="1.0" encoding="utf-8"?>
-<p:sld xmlns:a="http://schemas.openxmlformats.org/drawingml/2006/main" xmlns:p="http://schemas.openxmlformats.org/presentationml/2006/main" xmlns:r="http://schemas.openxmlformats.org/officeDocument/2006/relationships">
+<p:sld xmlns:a="http://schemas.openxmlformats.org/drawingml/2006/main" xmlns:r="http://schemas.openxmlformats.org/officeDocument/2006/relationships" xmlns:p="http://schemas.openxmlformats.org/presentationml/2006/main">
   <p:cSld>
     <p:spTree>
       <p:nvGrpSpPr>
@@ -4759,7 +4796,14 @@
         <p:cNvGrpSpPr/>
         <p:nvPr/>
       </p:nvGrpSpPr>
-      <p:grpSpPr/>
+      <p:grpSpPr>
+        <a:xfrm>
+          <a:off x="0" y="0"/>
+          <a:ext cx="0" cy="0"/>
+          <a:chOff x="0" y="0"/>
+          <a:chExt cx="0" cy="0"/>
+        </a:xfrm>
+      </p:grpSpPr>
       <p:sp>
         <p:nvSpPr>
           <p:cNvPr id="2" name="TextBox 1"/>
@@ -4872,6 +4916,7 @@
           <a:lstStyle/>
           <a:p>
             <a:pPr algn="ctr"/>
+            <a:endParaRPr/>
           </a:p>
         </p:txBody>
       </p:sp>
@@ -4917,6 +4962,7 @@
           <a:lstStyle/>
           <a:p>
             <a:pPr algn="ctr"/>
+            <a:endParaRPr/>
           </a:p>
         </p:txBody>
       </p:sp>
@@ -4943,7 +4989,7 @@
           <a:lstStyle/>
           <a:p>
             <a:pPr>
-              <a:defRPr b="1" sz="1300">
+              <a:defRPr sz="1300" b="1">
                 <a:solidFill>
                   <a:srgbClr val="1B365D"/>
                 </a:solidFill>
@@ -4974,10 +5020,34 @@
                 <a:tableStyleId>{5C22544A-7EE6-4342-B048-85BDC9FD1C3A}</a:tableStyleId>
               </a:tblPr>
               <a:tblGrid>
-                <a:gridCol w="2011680"/>
-                <a:gridCol w="1645920"/>
-                <a:gridCol w="5303520"/>
-                <a:gridCol w="1371600"/>
+                <a:gridCol w="2011680">
+                  <a:extLst>
+                    <a:ext uri="{9D8B030D-6E8A-4147-A177-3AD203B41FA5}">
+                      <a16:colId xmlns:a16="http://schemas.microsoft.com/office/drawing/2014/main" val="20000"/>
+                    </a:ext>
+                  </a:extLst>
+                </a:gridCol>
+                <a:gridCol w="1645920">
+                  <a:extLst>
+                    <a:ext uri="{9D8B030D-6E8A-4147-A177-3AD203B41FA5}">
+                      <a16:colId xmlns:a16="http://schemas.microsoft.com/office/drawing/2014/main" val="20001"/>
+                    </a:ext>
+                  </a:extLst>
+                </a:gridCol>
+                <a:gridCol w="5303520">
+                  <a:extLst>
+                    <a:ext uri="{9D8B030D-6E8A-4147-A177-3AD203B41FA5}">
+                      <a16:colId xmlns:a16="http://schemas.microsoft.com/office/drawing/2014/main" val="20002"/>
+                    </a:ext>
+                  </a:extLst>
+                </a:gridCol>
+                <a:gridCol w="1371600">
+                  <a:extLst>
+                    <a:ext uri="{9D8B030D-6E8A-4147-A177-3AD203B41FA5}">
+                      <a16:colId xmlns:a16="http://schemas.microsoft.com/office/drawing/2014/main" val="20003"/>
+                    </a:ext>
+                  </a:extLst>
+                </a:gridCol>
               </a:tblGrid>
               <a:tr h="1280160">
                 <a:tc>
@@ -4986,7 +5056,7 @@
                     <a:lstStyle/>
                     <a:p>
                       <a:pPr algn="ctr">
-                        <a:defRPr b="1" sz="1100">
+                        <a:defRPr sz="1100" b="1">
                           <a:solidFill>
                             <a:srgbClr val="FFFFFF"/>
                           </a:solidFill>
@@ -5009,7 +5079,7 @@
                     <a:lstStyle/>
                     <a:p>
                       <a:pPr algn="ctr">
-                        <a:defRPr b="1" sz="1100">
+                        <a:defRPr sz="1100" b="1">
                           <a:solidFill>
                             <a:srgbClr val="FFFFFF"/>
                           </a:solidFill>
@@ -5032,7 +5102,7 @@
                     <a:lstStyle/>
                     <a:p>
                       <a:pPr algn="ctr">
-                        <a:defRPr b="1" sz="1100">
+                        <a:defRPr sz="1100" b="1">
                           <a:solidFill>
                             <a:srgbClr val="FFFFFF"/>
                           </a:solidFill>
@@ -5055,7 +5125,7 @@
                     <a:lstStyle/>
                     <a:p>
                       <a:pPr algn="ctr">
-                        <a:defRPr b="1" sz="1100">
+                        <a:defRPr sz="1100" b="1">
                           <a:solidFill>
                             <a:srgbClr val="FFFFFF"/>
                           </a:solidFill>
@@ -5072,6 +5142,11 @@
                     </a:solidFill>
                   </a:tcPr>
                 </a:tc>
+                <a:extLst>
+                  <a:ext uri="{0D108BD9-81ED-4DB2-BD59-A6C34878D82A}">
+                    <a16:rowId xmlns:a16="http://schemas.microsoft.com/office/drawing/2014/main" val="10000"/>
+                  </a:ext>
+                </a:extLst>
               </a:tr>
               <a:tr h="1280160">
                 <a:tc>
@@ -5166,6 +5241,11 @@
                     </a:solidFill>
                   </a:tcPr>
                 </a:tc>
+                <a:extLst>
+                  <a:ext uri="{0D108BD9-81ED-4DB2-BD59-A6C34878D82A}">
+                    <a16:rowId xmlns:a16="http://schemas.microsoft.com/office/drawing/2014/main" val="10001"/>
+                  </a:ext>
+                </a:extLst>
               </a:tr>
               <a:tr h="1280160">
                 <a:tc>
@@ -5260,6 +5340,11 @@
                     </a:solidFill>
                   </a:tcPr>
                 </a:tc>
+                <a:extLst>
+                  <a:ext uri="{0D108BD9-81ED-4DB2-BD59-A6C34878D82A}">
+                    <a16:rowId xmlns:a16="http://schemas.microsoft.com/office/drawing/2014/main" val="10002"/>
+                  </a:ext>
+                </a:extLst>
               </a:tr>
             </a:tbl>
           </a:graphicData>
@@ -5274,7 +5359,7 @@
 </file>
 
 <file path=ppt/slides/slide14.xml><?xml version="1.0" encoding="utf-8"?>
-<p:sld xmlns:a="http://schemas.openxmlformats.org/drawingml/2006/main" xmlns:p="http://schemas.openxmlformats.org/presentationml/2006/main" xmlns:r="http://schemas.openxmlformats.org/officeDocument/2006/relationships">
+<p:sld xmlns:a="http://schemas.openxmlformats.org/drawingml/2006/main" xmlns:r="http://schemas.openxmlformats.org/officeDocument/2006/relationships" xmlns:p="http://schemas.openxmlformats.org/presentationml/2006/main">
   <p:cSld>
     <p:spTree>
       <p:nvGrpSpPr>
@@ -5282,7 +5367,14 @@
         <p:cNvGrpSpPr/>
         <p:nvPr/>
       </p:nvGrpSpPr>
-      <p:grpSpPr/>
+      <p:grpSpPr>
+        <a:xfrm>
+          <a:off x="0" y="0"/>
+          <a:ext cx="0" cy="0"/>
+          <a:chOff x="0" y="0"/>
+          <a:chExt cx="0" cy="0"/>
+        </a:xfrm>
+      </p:grpSpPr>
       <p:sp>
         <p:nvSpPr>
           <p:cNvPr id="2" name="TextBox 1"/>
@@ -5395,6 +5487,7 @@
           <a:lstStyle/>
           <a:p>
             <a:pPr algn="ctr"/>
+            <a:endParaRPr/>
           </a:p>
         </p:txBody>
       </p:sp>
@@ -5440,6 +5533,7 @@
           <a:lstStyle/>
           <a:p>
             <a:pPr algn="ctr"/>
+            <a:endParaRPr/>
           </a:p>
         </p:txBody>
       </p:sp>
@@ -5466,7 +5560,7 @@
           <a:lstStyle/>
           <a:p>
             <a:pPr>
-              <a:defRPr b="1" sz="1300">
+              <a:defRPr sz="1300" b="1">
                 <a:solidFill>
                   <a:srgbClr val="1B365D"/>
                 </a:solidFill>
@@ -5483,7 +5577,7 @@
               </a:spcBef>
             </a:pPr>
             <a:r>
-              <a:rPr b="1" sz="1100">
+              <a:rPr sz="1100" b="1">
                 <a:solidFill>
                   <a:srgbClr val="007AFF"/>
                 </a:solidFill>
@@ -5509,7 +5603,7 @@
               </a:spcBef>
             </a:pPr>
             <a:r>
-              <a:rPr b="1" sz="1100">
+              <a:rPr sz="1100" b="1">
                 <a:solidFill>
                   <a:srgbClr val="007AFF"/>
                 </a:solidFill>
@@ -5535,7 +5629,7 @@
               </a:spcBef>
             </a:pPr>
             <a:r>
-              <a:rPr b="1" sz="1100">
+              <a:rPr sz="1100" b="1">
                 <a:solidFill>
                   <a:srgbClr val="007AFF"/>
                 </a:solidFill>
@@ -5557,7 +5651,7 @@
               <a:spcBef>
                 <a:spcPts val="1600"/>
               </a:spcBef>
-              <a:defRPr b="1" sz="1400">
+              <a:defRPr sz="1400" b="1">
                 <a:solidFill>
                   <a:srgbClr val="1B365D"/>
                 </a:solidFill>
@@ -5578,7 +5672,7 @@
 </file>
 
 <file path=ppt/slides/slide2.xml><?xml version="1.0" encoding="utf-8"?>
-<p:sld xmlns:a="http://schemas.openxmlformats.org/drawingml/2006/main" xmlns:p="http://schemas.openxmlformats.org/presentationml/2006/main" xmlns:r="http://schemas.openxmlformats.org/officeDocument/2006/relationships">
+<p:sld xmlns:a="http://schemas.openxmlformats.org/drawingml/2006/main" xmlns:r="http://schemas.openxmlformats.org/officeDocument/2006/relationships" xmlns:p="http://schemas.openxmlformats.org/presentationml/2006/main">
   <p:cSld>
     <p:spTree>
       <p:nvGrpSpPr>
@@ -5586,7 +5680,14 @@
         <p:cNvGrpSpPr/>
         <p:nvPr/>
       </p:nvGrpSpPr>
-      <p:grpSpPr/>
+      <p:grpSpPr>
+        <a:xfrm>
+          <a:off x="0" y="0"/>
+          <a:ext cx="0" cy="0"/>
+          <a:chOff x="0" y="0"/>
+          <a:chExt cx="0" cy="0"/>
+        </a:xfrm>
+      </p:grpSpPr>
       <p:sp>
         <p:nvSpPr>
           <p:cNvPr id="2" name="TextBox 1"/>
@@ -5699,6 +5800,7 @@
           <a:lstStyle/>
           <a:p>
             <a:pPr algn="ctr"/>
+            <a:endParaRPr/>
           </a:p>
         </p:txBody>
       </p:sp>
@@ -5744,6 +5846,7 @@
           <a:lstStyle/>
           <a:p>
             <a:pPr algn="ctr"/>
+            <a:endParaRPr/>
           </a:p>
         </p:txBody>
       </p:sp>
@@ -5770,7 +5873,7 @@
           <a:lstStyle/>
           <a:p>
             <a:pPr>
-              <a:defRPr b="1" sz="1400">
+              <a:defRPr sz="1400" b="1">
                 <a:solidFill>
                   <a:srgbClr val="1B365D"/>
                 </a:solidFill>
@@ -5787,7 +5890,7 @@
               </a:spcBef>
             </a:pPr>
             <a:r>
-              <a:rPr b="1" sz="1100">
+              <a:rPr sz="1100" b="1">
                 <a:solidFill>
                   <a:srgbClr val="2B547E"/>
                 </a:solidFill>
@@ -5810,7 +5913,7 @@
               </a:spcBef>
             </a:pPr>
             <a:r>
-              <a:rPr b="1" sz="1100">
+              <a:rPr sz="1100" b="1">
                 <a:solidFill>
                   <a:srgbClr val="2B547E"/>
                 </a:solidFill>
@@ -5833,7 +5936,7 @@
               </a:spcBef>
             </a:pPr>
             <a:r>
-              <a:rPr b="1" sz="1100">
+              <a:rPr sz="1100" b="1">
                 <a:solidFill>
                   <a:srgbClr val="2B547E"/>
                 </a:solidFill>
@@ -5856,7 +5959,7 @@
               </a:spcBef>
             </a:pPr>
             <a:r>
-              <a:rPr b="1" sz="1100">
+              <a:rPr sz="1100" b="1">
                 <a:solidFill>
                   <a:srgbClr val="2B547E"/>
                 </a:solidFill>
@@ -5879,7 +5982,7 @@
               </a:spcBef>
             </a:pPr>
             <a:r>
-              <a:rPr b="1" sz="1100">
+              <a:rPr sz="1100" b="1">
                 <a:solidFill>
                   <a:srgbClr val="2B547E"/>
                 </a:solidFill>
@@ -5902,7 +6005,7 @@
               </a:spcBef>
             </a:pPr>
             <a:r>
-              <a:rPr b="1" sz="1100">
+              <a:rPr sz="1100" b="1">
                 <a:solidFill>
                   <a:srgbClr val="2B547E"/>
                 </a:solidFill>
@@ -5925,7 +6028,7 @@
               </a:spcBef>
             </a:pPr>
             <a:r>
-              <a:rPr b="1" sz="1100">
+              <a:rPr sz="1100" b="1">
                 <a:solidFill>
                   <a:srgbClr val="2B547E"/>
                 </a:solidFill>
@@ -5948,7 +6051,7 @@
               </a:spcBef>
             </a:pPr>
             <a:r>
-              <a:rPr b="1" sz="1100">
+              <a:rPr sz="1100" b="1">
                 <a:solidFill>
                   <a:srgbClr val="2B547E"/>
                 </a:solidFill>
@@ -6008,6 +6111,7 @@
           <a:lstStyle/>
           <a:p>
             <a:pPr algn="ctr"/>
+            <a:endParaRPr/>
           </a:p>
         </p:txBody>
       </p:sp>
@@ -6034,7 +6138,7 @@
           <a:lstStyle/>
           <a:p>
             <a:pPr>
-              <a:defRPr b="1" sz="1400">
+              <a:defRPr sz="1400" b="1">
                 <a:solidFill>
                   <a:srgbClr val="1B365D"/>
                 </a:solidFill>
@@ -6051,7 +6155,7 @@
               </a:spcBef>
             </a:pPr>
             <a:r>
-              <a:rPr b="1" sz="1200">
+              <a:rPr sz="1200" b="1">
                 <a:solidFill>
                   <a:srgbClr val="007AFF"/>
                 </a:solidFill>
@@ -6075,7 +6179,7 @@
               </a:spcBef>
             </a:pPr>
             <a:r>
-              <a:rPr b="1" sz="1200">
+              <a:rPr sz="1200" b="1">
                 <a:solidFill>
                   <a:srgbClr val="007AFF"/>
                 </a:solidFill>
@@ -6099,7 +6203,7 @@
               </a:spcBef>
             </a:pPr>
             <a:r>
-              <a:rPr b="1" sz="1200">
+              <a:rPr sz="1200" b="1">
                 <a:solidFill>
                   <a:srgbClr val="007AFF"/>
                 </a:solidFill>
@@ -6123,7 +6227,7 @@
               </a:spcBef>
             </a:pPr>
             <a:r>
-              <a:rPr b="1" sz="1200">
+              <a:rPr sz="1200" b="1">
                 <a:solidFill>
                   <a:srgbClr val="007AFF"/>
                 </a:solidFill>
@@ -6151,7 +6255,7 @@
 </file>
 
 <file path=ppt/slides/slide3.xml><?xml version="1.0" encoding="utf-8"?>
-<p:sld xmlns:a="http://schemas.openxmlformats.org/drawingml/2006/main" xmlns:p="http://schemas.openxmlformats.org/presentationml/2006/main" xmlns:r="http://schemas.openxmlformats.org/officeDocument/2006/relationships">
+<p:sld xmlns:a="http://schemas.openxmlformats.org/drawingml/2006/main" xmlns:r="http://schemas.openxmlformats.org/officeDocument/2006/relationships" xmlns:p="http://schemas.openxmlformats.org/presentationml/2006/main">
   <p:cSld>
     <p:spTree>
       <p:nvGrpSpPr>
@@ -6159,7 +6263,14 @@
         <p:cNvGrpSpPr/>
         <p:nvPr/>
       </p:nvGrpSpPr>
-      <p:grpSpPr/>
+      <p:grpSpPr>
+        <a:xfrm>
+          <a:off x="0" y="0"/>
+          <a:ext cx="0" cy="0"/>
+          <a:chOff x="0" y="0"/>
+          <a:chExt cx="0" cy="0"/>
+        </a:xfrm>
+      </p:grpSpPr>
       <p:sp>
         <p:nvSpPr>
           <p:cNvPr id="2" name="TextBox 1"/>
@@ -6272,6 +6383,7 @@
           <a:lstStyle/>
           <a:p>
             <a:pPr algn="ctr"/>
+            <a:endParaRPr/>
           </a:p>
         </p:txBody>
       </p:sp>
@@ -6317,6 +6429,7 @@
           <a:lstStyle/>
           <a:p>
             <a:pPr algn="ctr"/>
+            <a:endParaRPr/>
           </a:p>
         </p:txBody>
       </p:sp>
@@ -6367,7 +6480,7 @@
           <a:lstStyle/>
           <a:p>
             <a:pPr>
-              <a:defRPr b="1" sz="1100">
+              <a:defRPr sz="1100" b="1">
                 <a:solidFill>
                   <a:srgbClr val="1B365D"/>
                 </a:solidFill>
@@ -6437,6 +6550,7 @@
           <a:lstStyle/>
           <a:p>
             <a:pPr algn="ctr"/>
+            <a:endParaRPr/>
           </a:p>
         </p:txBody>
       </p:sp>
@@ -6487,7 +6601,7 @@
           <a:lstStyle/>
           <a:p>
             <a:pPr>
-              <a:defRPr b="1" sz="1100">
+              <a:defRPr sz="1100" b="1">
                 <a:solidFill>
                   <a:srgbClr val="1B365D"/>
                 </a:solidFill>
@@ -6557,6 +6671,7 @@
           <a:lstStyle/>
           <a:p>
             <a:pPr algn="ctr"/>
+            <a:endParaRPr/>
           </a:p>
         </p:txBody>
       </p:sp>
@@ -6607,7 +6722,7 @@
           <a:lstStyle/>
           <a:p>
             <a:pPr>
-              <a:defRPr b="1" sz="1100">
+              <a:defRPr sz="1100" b="1">
                 <a:solidFill>
                   <a:srgbClr val="1B365D"/>
                 </a:solidFill>
@@ -6644,7 +6759,7 @@
 </file>
 
 <file path=ppt/slides/slide4.xml><?xml version="1.0" encoding="utf-8"?>
-<p:sld xmlns:a="http://schemas.openxmlformats.org/drawingml/2006/main" xmlns:p="http://schemas.openxmlformats.org/presentationml/2006/main" xmlns:r="http://schemas.openxmlformats.org/officeDocument/2006/relationships">
+<p:sld xmlns:a="http://schemas.openxmlformats.org/drawingml/2006/main" xmlns:r="http://schemas.openxmlformats.org/officeDocument/2006/relationships" xmlns:p="http://schemas.openxmlformats.org/presentationml/2006/main">
   <p:cSld>
     <p:spTree>
       <p:nvGrpSpPr>
@@ -6652,7 +6767,14 @@
         <p:cNvGrpSpPr/>
         <p:nvPr/>
       </p:nvGrpSpPr>
-      <p:grpSpPr/>
+      <p:grpSpPr>
+        <a:xfrm>
+          <a:off x="0" y="0"/>
+          <a:ext cx="0" cy="0"/>
+          <a:chOff x="0" y="0"/>
+          <a:chExt cx="0" cy="0"/>
+        </a:xfrm>
+      </p:grpSpPr>
       <p:sp>
         <p:nvSpPr>
           <p:cNvPr id="2" name="TextBox 1"/>
@@ -6765,6 +6887,7 @@
           <a:lstStyle/>
           <a:p>
             <a:pPr algn="ctr"/>
+            <a:endParaRPr/>
           </a:p>
         </p:txBody>
       </p:sp>
@@ -6810,6 +6933,7 @@
           <a:lstStyle/>
           <a:p>
             <a:pPr algn="ctr"/>
+            <a:endParaRPr/>
           </a:p>
         </p:txBody>
       </p:sp>
@@ -6860,7 +6984,7 @@
           <a:lstStyle/>
           <a:p>
             <a:pPr>
-              <a:defRPr b="1" sz="1100">
+              <a:defRPr sz="1100" b="1">
                 <a:solidFill>
                   <a:srgbClr val="1B365D"/>
                 </a:solidFill>
@@ -6926,6 +7050,7 @@
           <a:lstStyle/>
           <a:p>
             <a:pPr algn="ctr"/>
+            <a:endParaRPr/>
           </a:p>
         </p:txBody>
       </p:sp>
@@ -6976,7 +7101,7 @@
           <a:lstStyle/>
           <a:p>
             <a:pPr>
-              <a:defRPr b="1" sz="1100">
+              <a:defRPr sz="1100" b="1">
                 <a:solidFill>
                   <a:srgbClr val="1B365D"/>
                 </a:solidFill>
@@ -7046,6 +7171,7 @@
           <a:lstStyle/>
           <a:p>
             <a:pPr algn="ctr"/>
+            <a:endParaRPr/>
           </a:p>
         </p:txBody>
       </p:sp>
@@ -7096,7 +7222,7 @@
           <a:lstStyle/>
           <a:p>
             <a:pPr>
-              <a:defRPr b="1" sz="1100">
+              <a:defRPr sz="1100" b="1">
                 <a:solidFill>
                   <a:srgbClr val="1B365D"/>
                 </a:solidFill>
@@ -7133,7 +7259,7 @@
 </file>
 
 <file path=ppt/slides/slide5.xml><?xml version="1.0" encoding="utf-8"?>
-<p:sld xmlns:a="http://schemas.openxmlformats.org/drawingml/2006/main" xmlns:p="http://schemas.openxmlformats.org/presentationml/2006/main" xmlns:r="http://schemas.openxmlformats.org/officeDocument/2006/relationships">
+<p:sld xmlns:a="http://schemas.openxmlformats.org/drawingml/2006/main" xmlns:r="http://schemas.openxmlformats.org/officeDocument/2006/relationships" xmlns:p="http://schemas.openxmlformats.org/presentationml/2006/main">
   <p:cSld>
     <p:spTree>
       <p:nvGrpSpPr>
@@ -7141,7 +7267,14 @@
         <p:cNvGrpSpPr/>
         <p:nvPr/>
       </p:nvGrpSpPr>
-      <p:grpSpPr/>
+      <p:grpSpPr>
+        <a:xfrm>
+          <a:off x="0" y="0"/>
+          <a:ext cx="0" cy="0"/>
+          <a:chOff x="0" y="0"/>
+          <a:chExt cx="0" cy="0"/>
+        </a:xfrm>
+      </p:grpSpPr>
       <p:sp>
         <p:nvSpPr>
           <p:cNvPr id="2" name="TextBox 1"/>
@@ -7254,6 +7387,7 @@
           <a:lstStyle/>
           <a:p>
             <a:pPr algn="ctr"/>
+            <a:endParaRPr/>
           </a:p>
         </p:txBody>
       </p:sp>
@@ -7299,6 +7433,7 @@
           <a:lstStyle/>
           <a:p>
             <a:pPr algn="ctr"/>
+            <a:endParaRPr/>
           </a:p>
         </p:txBody>
       </p:sp>
@@ -7325,7 +7460,7 @@
           <a:lstStyle/>
           <a:p>
             <a:pPr>
-              <a:defRPr b="1" sz="1200">
+              <a:defRPr sz="1200" b="1">
                 <a:solidFill>
                   <a:srgbClr val="1B365D"/>
                 </a:solidFill>
@@ -7398,6 +7533,7 @@
           <a:lstStyle/>
           <a:p>
             <a:pPr algn="ctr"/>
+            <a:endParaRPr/>
           </a:p>
         </p:txBody>
       </p:sp>
@@ -7424,7 +7560,7 @@
           <a:lstStyle/>
           <a:p>
             <a:pPr>
-              <a:defRPr b="1" sz="1200">
+              <a:defRPr sz="1200" b="1">
                 <a:solidFill>
                   <a:srgbClr val="1B365D"/>
                 </a:solidFill>
@@ -7497,6 +7633,7 @@
           <a:lstStyle/>
           <a:p>
             <a:pPr algn="ctr"/>
+            <a:endParaRPr/>
           </a:p>
         </p:txBody>
       </p:sp>
@@ -7523,7 +7660,7 @@
           <a:lstStyle/>
           <a:p>
             <a:pPr>
-              <a:defRPr b="1" sz="1200">
+              <a:defRPr sz="1200" b="1">
                 <a:solidFill>
                   <a:srgbClr val="1B365D"/>
                 </a:solidFill>
@@ -7596,6 +7733,7 @@
           <a:lstStyle/>
           <a:p>
             <a:pPr algn="ctr"/>
+            <a:endParaRPr/>
           </a:p>
         </p:txBody>
       </p:sp>
@@ -7622,7 +7760,7 @@
           <a:lstStyle/>
           <a:p>
             <a:pPr>
-              <a:defRPr b="1" sz="1200">
+              <a:defRPr sz="1200" b="1">
                 <a:solidFill>
                   <a:srgbClr val="1B365D"/>
                 </a:solidFill>
@@ -7662,7 +7800,7 @@
 </file>
 
 <file path=ppt/slides/slide6.xml><?xml version="1.0" encoding="utf-8"?>
-<p:sld xmlns:a="http://schemas.openxmlformats.org/drawingml/2006/main" xmlns:p="http://schemas.openxmlformats.org/presentationml/2006/main" xmlns:r="http://schemas.openxmlformats.org/officeDocument/2006/relationships">
+<p:sld xmlns:a="http://schemas.openxmlformats.org/drawingml/2006/main" xmlns:r="http://schemas.openxmlformats.org/officeDocument/2006/relationships" xmlns:p="http://schemas.openxmlformats.org/presentationml/2006/main">
   <p:cSld>
     <p:spTree>
       <p:nvGrpSpPr>
@@ -7670,7 +7808,14 @@
         <p:cNvGrpSpPr/>
         <p:nvPr/>
       </p:nvGrpSpPr>
-      <p:grpSpPr/>
+      <p:grpSpPr>
+        <a:xfrm>
+          <a:off x="0" y="0"/>
+          <a:ext cx="0" cy="0"/>
+          <a:chOff x="0" y="0"/>
+          <a:chExt cx="0" cy="0"/>
+        </a:xfrm>
+      </p:grpSpPr>
       <p:sp>
         <p:nvSpPr>
           <p:cNvPr id="2" name="TextBox 1"/>
@@ -7783,6 +7928,7 @@
           <a:lstStyle/>
           <a:p>
             <a:pPr algn="ctr"/>
+            <a:endParaRPr/>
           </a:p>
         </p:txBody>
       </p:sp>
@@ -7828,6 +7974,7 @@
           <a:lstStyle/>
           <a:p>
             <a:pPr algn="ctr"/>
+            <a:endParaRPr/>
           </a:p>
         </p:txBody>
       </p:sp>
@@ -7854,7 +8001,7 @@
           <a:lstStyle/>
           <a:p>
             <a:pPr>
-              <a:defRPr b="1" sz="1200">
+              <a:defRPr sz="1200" b="1">
                 <a:solidFill>
                   <a:srgbClr val="007AFF"/>
                 </a:solidFill>
@@ -7931,6 +8078,7 @@
           <a:lstStyle/>
           <a:p>
             <a:pPr algn="ctr"/>
+            <a:endParaRPr/>
           </a:p>
         </p:txBody>
       </p:sp>
@@ -7957,7 +8105,7 @@
           <a:lstStyle/>
           <a:p>
             <a:pPr>
-              <a:defRPr b="1" sz="1200">
+              <a:defRPr sz="1200" b="1">
                 <a:solidFill>
                   <a:srgbClr val="1B365D"/>
                 </a:solidFill>
@@ -8034,6 +8182,7 @@
           <a:lstStyle/>
           <a:p>
             <a:pPr algn="ctr"/>
+            <a:endParaRPr/>
           </a:p>
         </p:txBody>
       </p:sp>
@@ -8060,7 +8209,7 @@
           <a:lstStyle/>
           <a:p>
             <a:pPr>
-              <a:defRPr b="1" sz="1200">
+              <a:defRPr sz="1200" b="1">
                 <a:solidFill>
                   <a:srgbClr val="1B365D"/>
                 </a:solidFill>
@@ -8137,6 +8286,7 @@
           <a:lstStyle/>
           <a:p>
             <a:pPr algn="ctr"/>
+            <a:endParaRPr/>
           </a:p>
         </p:txBody>
       </p:sp>
@@ -8163,7 +8313,7 @@
           <a:lstStyle/>
           <a:p>
             <a:pPr>
-              <a:defRPr b="1" sz="1200">
+              <a:defRPr sz="1200" b="1">
                 <a:solidFill>
                   <a:srgbClr val="1B365D"/>
                 </a:solidFill>
@@ -8207,7 +8357,7 @@
 </file>
 
 <file path=ppt/slides/slide7.xml><?xml version="1.0" encoding="utf-8"?>
-<p:sld xmlns:a="http://schemas.openxmlformats.org/drawingml/2006/main" xmlns:p="http://schemas.openxmlformats.org/presentationml/2006/main" xmlns:r="http://schemas.openxmlformats.org/officeDocument/2006/relationships">
+<p:sld xmlns:a="http://schemas.openxmlformats.org/drawingml/2006/main" xmlns:r="http://schemas.openxmlformats.org/officeDocument/2006/relationships" xmlns:p="http://schemas.openxmlformats.org/presentationml/2006/main">
   <p:cSld>
     <p:spTree>
       <p:nvGrpSpPr>
@@ -8215,7 +8365,14 @@
         <p:cNvGrpSpPr/>
         <p:nvPr/>
       </p:nvGrpSpPr>
-      <p:grpSpPr/>
+      <p:grpSpPr>
+        <a:xfrm>
+          <a:off x="0" y="0"/>
+          <a:ext cx="0" cy="0"/>
+          <a:chOff x="0" y="0"/>
+          <a:chExt cx="0" cy="0"/>
+        </a:xfrm>
+      </p:grpSpPr>
       <p:sp>
         <p:nvSpPr>
           <p:cNvPr id="2" name="TextBox 1"/>
@@ -8328,6 +8485,7 @@
           <a:lstStyle/>
           <a:p>
             <a:pPr algn="ctr"/>
+            <a:endParaRPr/>
           </a:p>
         </p:txBody>
       </p:sp>
@@ -8373,6 +8531,7 @@
           <a:lstStyle/>
           <a:p>
             <a:pPr algn="ctr"/>
+            <a:endParaRPr/>
           </a:p>
         </p:txBody>
       </p:sp>
@@ -8399,7 +8558,7 @@
           <a:lstStyle/>
           <a:p>
             <a:pPr>
-              <a:defRPr b="1" sz="1200">
+              <a:defRPr sz="1200" b="1">
                 <a:solidFill>
                   <a:srgbClr val="1B365D"/>
                 </a:solidFill>
@@ -8430,12 +8589,48 @@
                 <a:tableStyleId>{5C22544A-7EE6-4342-B048-85BDC9FD1C3A}</a:tableStyleId>
               </a:tblPr>
               <a:tblGrid>
-                <a:gridCol w="1828800"/>
-                <a:gridCol w="822960"/>
-                <a:gridCol w="822960"/>
-                <a:gridCol w="822960"/>
-                <a:gridCol w="822960"/>
-                <a:gridCol w="1371600"/>
+                <a:gridCol w="1828800">
+                  <a:extLst>
+                    <a:ext uri="{9D8B030D-6E8A-4147-A177-3AD203B41FA5}">
+                      <a16:colId xmlns:a16="http://schemas.microsoft.com/office/drawing/2014/main" val="20000"/>
+                    </a:ext>
+                  </a:extLst>
+                </a:gridCol>
+                <a:gridCol w="822960">
+                  <a:extLst>
+                    <a:ext uri="{9D8B030D-6E8A-4147-A177-3AD203B41FA5}">
+                      <a16:colId xmlns:a16="http://schemas.microsoft.com/office/drawing/2014/main" val="20001"/>
+                    </a:ext>
+                  </a:extLst>
+                </a:gridCol>
+                <a:gridCol w="822960">
+                  <a:extLst>
+                    <a:ext uri="{9D8B030D-6E8A-4147-A177-3AD203B41FA5}">
+                      <a16:colId xmlns:a16="http://schemas.microsoft.com/office/drawing/2014/main" val="20002"/>
+                    </a:ext>
+                  </a:extLst>
+                </a:gridCol>
+                <a:gridCol w="822960">
+                  <a:extLst>
+                    <a:ext uri="{9D8B030D-6E8A-4147-A177-3AD203B41FA5}">
+                      <a16:colId xmlns:a16="http://schemas.microsoft.com/office/drawing/2014/main" val="20003"/>
+                    </a:ext>
+                  </a:extLst>
+                </a:gridCol>
+                <a:gridCol w="822960">
+                  <a:extLst>
+                    <a:ext uri="{9D8B030D-6E8A-4147-A177-3AD203B41FA5}">
+                      <a16:colId xmlns:a16="http://schemas.microsoft.com/office/drawing/2014/main" val="20004"/>
+                    </a:ext>
+                  </a:extLst>
+                </a:gridCol>
+                <a:gridCol w="1371600">
+                  <a:extLst>
+                    <a:ext uri="{9D8B030D-6E8A-4147-A177-3AD203B41FA5}">
+                      <a16:colId xmlns:a16="http://schemas.microsoft.com/office/drawing/2014/main" val="20005"/>
+                    </a:ext>
+                  </a:extLst>
+                </a:gridCol>
               </a:tblGrid>
               <a:tr h="587828">
                 <a:tc>
@@ -8444,7 +8639,7 @@
                     <a:lstStyle/>
                     <a:p>
                       <a:pPr algn="ctr">
-                        <a:defRPr b="1" sz="1000">
+                        <a:defRPr sz="1000" b="1">
                           <a:solidFill>
                             <a:srgbClr val="FFFFFF"/>
                           </a:solidFill>
@@ -8467,7 +8662,7 @@
                     <a:lstStyle/>
                     <a:p>
                       <a:pPr algn="ctr">
-                        <a:defRPr b="1" sz="1000">
+                        <a:defRPr sz="1000" b="1">
                           <a:solidFill>
                             <a:srgbClr val="FFFFFF"/>
                           </a:solidFill>
@@ -8490,7 +8685,7 @@
                     <a:lstStyle/>
                     <a:p>
                       <a:pPr algn="ctr">
-                        <a:defRPr b="1" sz="1000">
+                        <a:defRPr sz="1000" b="1">
                           <a:solidFill>
                             <a:srgbClr val="FFFFFF"/>
                           </a:solidFill>
@@ -8513,7 +8708,7 @@
                     <a:lstStyle/>
                     <a:p>
                       <a:pPr algn="ctr">
-                        <a:defRPr b="1" sz="1000">
+                        <a:defRPr sz="1000" b="1">
                           <a:solidFill>
                             <a:srgbClr val="FFFFFF"/>
                           </a:solidFill>
@@ -8536,7 +8731,7 @@
                     <a:lstStyle/>
                     <a:p>
                       <a:pPr algn="ctr">
-                        <a:defRPr b="1" sz="1000">
+                        <a:defRPr sz="1000" b="1">
                           <a:solidFill>
                             <a:srgbClr val="FFFFFF"/>
                           </a:solidFill>
@@ -8559,7 +8754,7 @@
                     <a:lstStyle/>
                     <a:p>
                       <a:pPr algn="ctr">
-                        <a:defRPr b="1" sz="1000">
+                        <a:defRPr sz="1000" b="1">
                           <a:solidFill>
                             <a:srgbClr val="FFFFFF"/>
                           </a:solidFill>
@@ -8576,6 +8771,11 @@
                     </a:solidFill>
                   </a:tcPr>
                 </a:tc>
+                <a:extLst>
+                  <a:ext uri="{0D108BD9-81ED-4DB2-BD59-A6C34878D82A}">
+                    <a16:rowId xmlns:a16="http://schemas.microsoft.com/office/drawing/2014/main" val="10000"/>
+                  </a:ext>
+                </a:extLst>
               </a:tr>
               <a:tr h="587828">
                 <a:tc>
@@ -8716,6 +8916,11 @@
                     </a:solidFill>
                   </a:tcPr>
                 </a:tc>
+                <a:extLst>
+                  <a:ext uri="{0D108BD9-81ED-4DB2-BD59-A6C34878D82A}">
+                    <a16:rowId xmlns:a16="http://schemas.microsoft.com/office/drawing/2014/main" val="10001"/>
+                  </a:ext>
+                </a:extLst>
               </a:tr>
               <a:tr h="587828">
                 <a:tc>
@@ -8832,6 +9037,11 @@
                     </a:solidFill>
                   </a:tcPr>
                 </a:tc>
+                <a:extLst>
+                  <a:ext uri="{0D108BD9-81ED-4DB2-BD59-A6C34878D82A}">
+                    <a16:rowId xmlns:a16="http://schemas.microsoft.com/office/drawing/2014/main" val="10002"/>
+                  </a:ext>
+                </a:extLst>
               </a:tr>
               <a:tr h="587828">
                 <a:tc>
@@ -8948,6 +9158,11 @@
                     </a:solidFill>
                   </a:tcPr>
                 </a:tc>
+                <a:extLst>
+                  <a:ext uri="{0D108BD9-81ED-4DB2-BD59-A6C34878D82A}">
+                    <a16:rowId xmlns:a16="http://schemas.microsoft.com/office/drawing/2014/main" val="10003"/>
+                  </a:ext>
+                </a:extLst>
               </a:tr>
               <a:tr h="587828">
                 <a:tc>
@@ -9064,6 +9279,11 @@
                     </a:solidFill>
                   </a:tcPr>
                 </a:tc>
+                <a:extLst>
+                  <a:ext uri="{0D108BD9-81ED-4DB2-BD59-A6C34878D82A}">
+                    <a16:rowId xmlns:a16="http://schemas.microsoft.com/office/drawing/2014/main" val="10004"/>
+                  </a:ext>
+                </a:extLst>
               </a:tr>
               <a:tr h="587828">
                 <a:tc>
@@ -9180,6 +9400,11 @@
                     </a:solidFill>
                   </a:tcPr>
                 </a:tc>
+                <a:extLst>
+                  <a:ext uri="{0D108BD9-81ED-4DB2-BD59-A6C34878D82A}">
+                    <a16:rowId xmlns:a16="http://schemas.microsoft.com/office/drawing/2014/main" val="10005"/>
+                  </a:ext>
+                </a:extLst>
               </a:tr>
               <a:tr h="587832">
                 <a:tc>
@@ -9296,6 +9521,11 @@
                     </a:solidFill>
                   </a:tcPr>
                 </a:tc>
+                <a:extLst>
+                  <a:ext uri="{0D108BD9-81ED-4DB2-BD59-A6C34878D82A}">
+                    <a16:rowId xmlns:a16="http://schemas.microsoft.com/office/drawing/2014/main" val="10006"/>
+                  </a:ext>
+                </a:extLst>
               </a:tr>
             </a:tbl>
           </a:graphicData>
@@ -9343,6 +9573,7 @@
           <a:lstStyle/>
           <a:p>
             <a:pPr algn="ctr"/>
+            <a:endParaRPr/>
           </a:p>
         </p:txBody>
       </p:sp>
@@ -9378,7 +9609,7 @@
         </p:nvSpPr>
         <p:spPr>
           <a:xfrm>
-            <a:off x="7863840" y="4023360"/>
+            <a:off x="7863840" y="4663440"/>
             <a:ext cx="3474720" cy="2194560"/>
           </a:xfrm>
           <a:prstGeom prst="rect">
@@ -9393,13 +9624,14 @@
           <a:lstStyle/>
           <a:p>
             <a:pPr>
-              <a:defRPr b="1" sz="1100">
+              <a:defRPr sz="1100" b="1">
                 <a:solidFill>
                   <a:srgbClr val="1B365D"/>
                 </a:solidFill>
               </a:defRPr>
             </a:pPr>
             <a:r>
+              <a:rPr dirty="0"/>
               <a:t>LÝ DO CHỌN LOGISTIC REGRESSION</a:t>
             </a:r>
           </a:p>
@@ -9408,19 +9640,237 @@
               <a:defRPr sz="1000"/>
             </a:pPr>
             <a:r>
-              <a:t>1. Độ chính xác cao nhất (97.50%).</a:t>
-            </a:r>
-            <a:br/>
-            <a:r>
-              <a:t>2. Không bị quá khớp (chênh lệch Train - Test chỉ 0.75%).</a:t>
-            </a:r>
-            <a:br/>
-            <a:r>
-              <a:t>3. File siêu nhẹ (2.1 KB), latency &lt; 5ms.</a:t>
-            </a:r>
-            <a:br/>
-            <a:r>
-              <a:t>4. Ma trận nhầm lẫn: 100% nhầm ở ranh giới lớp liền kề, không nhảy cóc.</a:t>
+              <a:rPr dirty="0"/>
+              <a:t>1. </a:t>
+            </a:r>
+            <a:r>
+              <a:rPr dirty="0" err="1"/>
+              <a:t>Độ</a:t>
+            </a:r>
+            <a:r>
+              <a:rPr dirty="0"/>
+              <a:t> </a:t>
+            </a:r>
+            <a:r>
+              <a:rPr dirty="0" err="1"/>
+              <a:t>chính</a:t>
+            </a:r>
+            <a:r>
+              <a:rPr dirty="0"/>
+              <a:t> </a:t>
+            </a:r>
+            <a:r>
+              <a:rPr dirty="0" err="1"/>
+              <a:t>xác</a:t>
+            </a:r>
+            <a:r>
+              <a:rPr dirty="0"/>
+              <a:t> </a:t>
+            </a:r>
+            <a:r>
+              <a:rPr dirty="0" err="1"/>
+              <a:t>cao</a:t>
+            </a:r>
+            <a:r>
+              <a:rPr dirty="0"/>
+              <a:t> </a:t>
+            </a:r>
+            <a:r>
+              <a:rPr dirty="0" err="1"/>
+              <a:t>nhất</a:t>
+            </a:r>
+            <a:r>
+              <a:rPr dirty="0"/>
+              <a:t> (97.50%).</a:t>
+            </a:r>
+            <a:br>
+              <a:rPr dirty="0"/>
+            </a:br>
+            <a:r>
+              <a:rPr dirty="0"/>
+              <a:t>2. </a:t>
+            </a:r>
+            <a:r>
+              <a:rPr dirty="0" err="1"/>
+              <a:t>Không</a:t>
+            </a:r>
+            <a:r>
+              <a:rPr dirty="0"/>
+              <a:t> </a:t>
+            </a:r>
+            <a:r>
+              <a:rPr dirty="0" err="1"/>
+              <a:t>bị</a:t>
+            </a:r>
+            <a:r>
+              <a:rPr dirty="0"/>
+              <a:t> </a:t>
+            </a:r>
+            <a:r>
+              <a:rPr dirty="0" err="1"/>
+              <a:t>quá</a:t>
+            </a:r>
+            <a:r>
+              <a:rPr dirty="0"/>
+              <a:t> </a:t>
+            </a:r>
+            <a:r>
+              <a:rPr dirty="0" err="1"/>
+              <a:t>khớp</a:t>
+            </a:r>
+            <a:r>
+              <a:rPr dirty="0"/>
+              <a:t> (</a:t>
+            </a:r>
+            <a:r>
+              <a:rPr dirty="0" err="1"/>
+              <a:t>chênh</a:t>
+            </a:r>
+            <a:r>
+              <a:rPr dirty="0"/>
+              <a:t> </a:t>
+            </a:r>
+            <a:r>
+              <a:rPr dirty="0" err="1"/>
+              <a:t>lệch</a:t>
+            </a:r>
+            <a:r>
+              <a:rPr dirty="0"/>
+              <a:t> Train - Test </a:t>
+            </a:r>
+            <a:r>
+              <a:rPr dirty="0" err="1"/>
+              <a:t>chỉ</a:t>
+            </a:r>
+            <a:r>
+              <a:rPr dirty="0"/>
+              <a:t> 0.75%).</a:t>
+            </a:r>
+            <a:br>
+              <a:rPr dirty="0"/>
+            </a:br>
+            <a:r>
+              <a:rPr dirty="0"/>
+              <a:t>3. File </a:t>
+            </a:r>
+            <a:r>
+              <a:rPr dirty="0" err="1"/>
+              <a:t>siêu</a:t>
+            </a:r>
+            <a:r>
+              <a:rPr dirty="0"/>
+              <a:t> </a:t>
+            </a:r>
+            <a:r>
+              <a:rPr dirty="0" err="1"/>
+              <a:t>nhẹ</a:t>
+            </a:r>
+            <a:r>
+              <a:rPr dirty="0"/>
+              <a:t> (2.1 KB), latency &lt; 5ms.</a:t>
+            </a:r>
+            <a:br>
+              <a:rPr dirty="0"/>
+            </a:br>
+            <a:r>
+              <a:rPr dirty="0"/>
+              <a:t>4. Ma </a:t>
+            </a:r>
+            <a:r>
+              <a:rPr dirty="0" err="1"/>
+              <a:t>trận</a:t>
+            </a:r>
+            <a:r>
+              <a:rPr dirty="0"/>
+              <a:t> </a:t>
+            </a:r>
+            <a:r>
+              <a:rPr dirty="0" err="1"/>
+              <a:t>nhầm</a:t>
+            </a:r>
+            <a:r>
+              <a:rPr dirty="0"/>
+              <a:t> </a:t>
+            </a:r>
+            <a:r>
+              <a:rPr dirty="0" err="1"/>
+              <a:t>lẫn</a:t>
+            </a:r>
+            <a:r>
+              <a:rPr dirty="0"/>
+              <a:t>: 100% </a:t>
+            </a:r>
+            <a:r>
+              <a:rPr dirty="0" err="1"/>
+              <a:t>nhầm</a:t>
+            </a:r>
+            <a:r>
+              <a:rPr dirty="0"/>
+              <a:t> ở </a:t>
+            </a:r>
+            <a:r>
+              <a:rPr dirty="0" err="1"/>
+              <a:t>ranh</a:t>
+            </a:r>
+            <a:r>
+              <a:rPr dirty="0"/>
+              <a:t> </a:t>
+            </a:r>
+            <a:r>
+              <a:rPr dirty="0" err="1"/>
+              <a:t>giới</a:t>
+            </a:r>
+            <a:r>
+              <a:rPr dirty="0"/>
+              <a:t> </a:t>
+            </a:r>
+            <a:r>
+              <a:rPr dirty="0" err="1"/>
+              <a:t>lớp</a:t>
+            </a:r>
+            <a:r>
+              <a:rPr dirty="0"/>
+              <a:t> </a:t>
+            </a:r>
+            <a:r>
+              <a:rPr dirty="0" err="1"/>
+              <a:t>liền</a:t>
+            </a:r>
+            <a:r>
+              <a:rPr dirty="0"/>
+              <a:t> </a:t>
+            </a:r>
+            <a:r>
+              <a:rPr dirty="0" err="1"/>
+              <a:t>kề</a:t>
+            </a:r>
+            <a:r>
+              <a:rPr dirty="0"/>
+              <a:t>, </a:t>
+            </a:r>
+            <a:r>
+              <a:rPr dirty="0" err="1"/>
+              <a:t>không</a:t>
+            </a:r>
+            <a:r>
+              <a:rPr dirty="0"/>
+              <a:t> </a:t>
+            </a:r>
+            <a:r>
+              <a:rPr dirty="0" err="1"/>
+              <a:t>nhảy</a:t>
+            </a:r>
+            <a:r>
+              <a:rPr dirty="0"/>
+              <a:t> </a:t>
+            </a:r>
+            <a:r>
+              <a:rPr dirty="0" err="1"/>
+              <a:t>cóc</a:t>
+            </a:r>
+            <a:r>
+              <a:rPr dirty="0"/>
+              <a:t>.</a:t>
             </a:r>
           </a:p>
         </p:txBody>
@@ -9434,7 +9884,7 @@
 </file>
 
 <file path=ppt/slides/slide8.xml><?xml version="1.0" encoding="utf-8"?>
-<p:sld xmlns:a="http://schemas.openxmlformats.org/drawingml/2006/main" xmlns:p="http://schemas.openxmlformats.org/presentationml/2006/main" xmlns:r="http://schemas.openxmlformats.org/officeDocument/2006/relationships">
+<p:sld xmlns:a="http://schemas.openxmlformats.org/drawingml/2006/main" xmlns:r="http://schemas.openxmlformats.org/officeDocument/2006/relationships" xmlns:p="http://schemas.openxmlformats.org/presentationml/2006/main">
   <p:cSld>
     <p:spTree>
       <p:nvGrpSpPr>
@@ -9442,7 +9892,14 @@
         <p:cNvGrpSpPr/>
         <p:nvPr/>
       </p:nvGrpSpPr>
-      <p:grpSpPr/>
+      <p:grpSpPr>
+        <a:xfrm>
+          <a:off x="0" y="0"/>
+          <a:ext cx="0" cy="0"/>
+          <a:chOff x="0" y="0"/>
+          <a:chExt cx="0" cy="0"/>
+        </a:xfrm>
+      </p:grpSpPr>
       <p:sp>
         <p:nvSpPr>
           <p:cNvPr id="2" name="TextBox 1"/>
@@ -9555,6 +10012,7 @@
           <a:lstStyle/>
           <a:p>
             <a:pPr algn="ctr"/>
+            <a:endParaRPr/>
           </a:p>
         </p:txBody>
       </p:sp>
@@ -9600,6 +10058,7 @@
           <a:lstStyle/>
           <a:p>
             <a:pPr algn="ctr"/>
+            <a:endParaRPr/>
           </a:p>
         </p:txBody>
       </p:sp>
@@ -9626,7 +10085,7 @@
           <a:lstStyle/>
           <a:p>
             <a:pPr>
-              <a:defRPr b="1" sz="1200">
+              <a:defRPr sz="1200" b="1">
                 <a:solidFill>
                   <a:srgbClr val="1B365D"/>
                 </a:solidFill>
@@ -9707,6 +10166,7 @@
           <a:lstStyle/>
           <a:p>
             <a:pPr algn="ctr"/>
+            <a:endParaRPr/>
           </a:p>
         </p:txBody>
       </p:sp>
@@ -9733,7 +10193,7 @@
           <a:lstStyle/>
           <a:p>
             <a:pPr>
-              <a:defRPr b="1" sz="1200">
+              <a:defRPr sz="1200" b="1">
                 <a:solidFill>
                   <a:srgbClr val="1B365D"/>
                 </a:solidFill>
@@ -9814,6 +10274,7 @@
           <a:lstStyle/>
           <a:p>
             <a:pPr algn="ctr"/>
+            <a:endParaRPr/>
           </a:p>
         </p:txBody>
       </p:sp>
@@ -9840,7 +10301,7 @@
           <a:lstStyle/>
           <a:p>
             <a:pPr>
-              <a:defRPr b="1" sz="1200">
+              <a:defRPr sz="1200" b="1">
                 <a:solidFill>
                   <a:srgbClr val="1B365D"/>
                 </a:solidFill>
@@ -9917,6 +10378,7 @@
           <a:lstStyle/>
           <a:p>
             <a:pPr algn="ctr"/>
+            <a:endParaRPr/>
           </a:p>
         </p:txBody>
       </p:sp>
@@ -9943,7 +10405,7 @@
           <a:lstStyle/>
           <a:p>
             <a:pPr>
-              <a:defRPr b="1" sz="1100">
+              <a:defRPr sz="1100" b="1">
                 <a:solidFill>
                   <a:srgbClr val="007AFF"/>
                 </a:solidFill>
@@ -9980,7 +10442,7 @@
 </file>
 
 <file path=ppt/slides/slide9.xml><?xml version="1.0" encoding="utf-8"?>
-<p:sld xmlns:a="http://schemas.openxmlformats.org/drawingml/2006/main" xmlns:p="http://schemas.openxmlformats.org/presentationml/2006/main" xmlns:r="http://schemas.openxmlformats.org/officeDocument/2006/relationships">
+<p:sld xmlns:a="http://schemas.openxmlformats.org/drawingml/2006/main" xmlns:r="http://schemas.openxmlformats.org/officeDocument/2006/relationships" xmlns:p="http://schemas.openxmlformats.org/presentationml/2006/main">
   <p:cSld>
     <p:spTree>
       <p:nvGrpSpPr>
@@ -9988,7 +10450,14 @@
         <p:cNvGrpSpPr/>
         <p:nvPr/>
       </p:nvGrpSpPr>
-      <p:grpSpPr/>
+      <p:grpSpPr>
+        <a:xfrm>
+          <a:off x="0" y="0"/>
+          <a:ext cx="0" cy="0"/>
+          <a:chOff x="0" y="0"/>
+          <a:chExt cx="0" cy="0"/>
+        </a:xfrm>
+      </p:grpSpPr>
       <p:sp>
         <p:nvSpPr>
           <p:cNvPr id="2" name="TextBox 1"/>
@@ -10101,6 +10570,7 @@
           <a:lstStyle/>
           <a:p>
             <a:pPr algn="ctr"/>
+            <a:endParaRPr/>
           </a:p>
         </p:txBody>
       </p:sp>
@@ -10146,6 +10616,7 @@
           <a:lstStyle/>
           <a:p>
             <a:pPr algn="ctr"/>
+            <a:endParaRPr/>
           </a:p>
         </p:txBody>
       </p:sp>
@@ -10172,7 +10643,7 @@
           <a:lstStyle/>
           <a:p>
             <a:pPr>
-              <a:defRPr b="1" sz="1100">
+              <a:defRPr sz="1100" b="1">
                 <a:solidFill>
                   <a:srgbClr val="1B365D"/>
                 </a:solidFill>
@@ -10253,6 +10724,7 @@
           <a:lstStyle/>
           <a:p>
             <a:pPr algn="ctr"/>
+            <a:endParaRPr/>
           </a:p>
         </p:txBody>
       </p:sp>
@@ -10279,7 +10751,7 @@
           <a:lstStyle/>
           <a:p>
             <a:pPr>
-              <a:defRPr b="1" sz="1100">
+              <a:defRPr sz="1100" b="1">
                 <a:solidFill>
                   <a:srgbClr val="1B365D"/>
                 </a:solidFill>
@@ -10348,6 +10820,7 @@
           <a:lstStyle/>
           <a:p>
             <a:pPr algn="ctr"/>
+            <a:endParaRPr/>
           </a:p>
         </p:txBody>
       </p:sp>
@@ -10374,7 +10847,7 @@
           <a:lstStyle/>
           <a:p>
             <a:pPr>
-              <a:defRPr b="1" sz="1100">
+              <a:defRPr sz="1100" b="1">
                 <a:solidFill>
                   <a:srgbClr val="1B365D"/>
                 </a:solidFill>
@@ -10443,6 +10916,7 @@
           <a:lstStyle/>
           <a:p>
             <a:pPr algn="ctr"/>
+            <a:endParaRPr/>
           </a:p>
         </p:txBody>
       </p:sp>
@@ -10469,7 +10943,7 @@
           <a:lstStyle/>
           <a:p>
             <a:pPr>
-              <a:defRPr b="1" sz="1100">
+              <a:defRPr sz="1100" b="1">
                 <a:solidFill>
                   <a:srgbClr val="1B365D"/>
                 </a:solidFill>
@@ -10538,6 +11012,7 @@
           <a:lstStyle/>
           <a:p>
             <a:pPr algn="ctr"/>
+            <a:endParaRPr/>
           </a:p>
         </p:txBody>
       </p:sp>
@@ -10564,7 +11039,7 @@
           <a:lstStyle/>
           <a:p>
             <a:pPr>
-              <a:defRPr b="1" sz="1100">
+              <a:defRPr sz="1100" b="1">
                 <a:solidFill>
                   <a:srgbClr val="1B365D"/>
                 </a:solidFill>

</xml_diff>

<commit_message>
cap nhat lai slide thuyet trinh
</commit_message>
<xml_diff>
--- a/docs/nhom_15_10123334_10123343_Phan_loai_khoang_gia_dien_thoai.pptx
+++ b/docs/nhom_15_10123334_10123343_Phan_loai_khoang_gia_dien_thoai.pptx
@@ -315,7 +315,7 @@
           <a:p>
             <a:fld id="{5BCAD085-E8A6-8845-BD4E-CB4CCA059FC4}" type="datetimeFigureOut">
               <a:rPr lang="en-US" smtClean="0"/>
-              <a:t>9/27/2026</a:t>
+              <a:t>10/2/2026</a:t>
             </a:fld>
             <a:endParaRPr lang="en-US"/>
           </a:p>
@@ -483,7 +483,7 @@
           <a:p>
             <a:fld id="{5BCAD085-E8A6-8845-BD4E-CB4CCA059FC4}" type="datetimeFigureOut">
               <a:rPr lang="en-US" smtClean="0"/>
-              <a:t>9/27/2026</a:t>
+              <a:t>10/2/2026</a:t>
             </a:fld>
             <a:endParaRPr lang="en-US"/>
           </a:p>
@@ -661,7 +661,7 @@
           <a:p>
             <a:fld id="{5BCAD085-E8A6-8845-BD4E-CB4CCA059FC4}" type="datetimeFigureOut">
               <a:rPr lang="en-US" smtClean="0"/>
-              <a:t>9/27/2026</a:t>
+              <a:t>10/2/2026</a:t>
             </a:fld>
             <a:endParaRPr lang="en-US"/>
           </a:p>
@@ -829,7 +829,7 @@
           <a:p>
             <a:fld id="{5BCAD085-E8A6-8845-BD4E-CB4CCA059FC4}" type="datetimeFigureOut">
               <a:rPr lang="en-US" smtClean="0"/>
-              <a:t>9/27/2026</a:t>
+              <a:t>10/2/2026</a:t>
             </a:fld>
             <a:endParaRPr lang="en-US"/>
           </a:p>
@@ -1074,7 +1074,7 @@
           <a:p>
             <a:fld id="{5BCAD085-E8A6-8845-BD4E-CB4CCA059FC4}" type="datetimeFigureOut">
               <a:rPr lang="en-US" smtClean="0"/>
-              <a:t>9/27/2026</a:t>
+              <a:t>10/2/2026</a:t>
             </a:fld>
             <a:endParaRPr lang="en-US"/>
           </a:p>
@@ -1359,7 +1359,7 @@
           <a:p>
             <a:fld id="{5BCAD085-E8A6-8845-BD4E-CB4CCA059FC4}" type="datetimeFigureOut">
               <a:rPr lang="en-US" smtClean="0"/>
-              <a:t>9/27/2026</a:t>
+              <a:t>10/2/2026</a:t>
             </a:fld>
             <a:endParaRPr lang="en-US"/>
           </a:p>
@@ -1778,7 +1778,7 @@
           <a:p>
             <a:fld id="{5BCAD085-E8A6-8845-BD4E-CB4CCA059FC4}" type="datetimeFigureOut">
               <a:rPr lang="en-US" smtClean="0"/>
-              <a:t>9/27/2026</a:t>
+              <a:t>10/2/2026</a:t>
             </a:fld>
             <a:endParaRPr lang="en-US"/>
           </a:p>
@@ -1895,7 +1895,7 @@
           <a:p>
             <a:fld id="{5BCAD085-E8A6-8845-BD4E-CB4CCA059FC4}" type="datetimeFigureOut">
               <a:rPr lang="en-US" smtClean="0"/>
-              <a:t>9/27/2026</a:t>
+              <a:t>10/2/2026</a:t>
             </a:fld>
             <a:endParaRPr lang="en-US"/>
           </a:p>
@@ -1990,7 +1990,7 @@
           <a:p>
             <a:fld id="{5BCAD085-E8A6-8845-BD4E-CB4CCA059FC4}" type="datetimeFigureOut">
               <a:rPr lang="en-US" smtClean="0"/>
-              <a:t>9/27/2026</a:t>
+              <a:t>10/2/2026</a:t>
             </a:fld>
             <a:endParaRPr lang="en-US"/>
           </a:p>
@@ -2265,7 +2265,7 @@
           <a:p>
             <a:fld id="{5BCAD085-E8A6-8845-BD4E-CB4CCA059FC4}" type="datetimeFigureOut">
               <a:rPr lang="en-US" smtClean="0"/>
-              <a:t>9/27/2026</a:t>
+              <a:t>10/2/2026</a:t>
             </a:fld>
             <a:endParaRPr lang="en-US"/>
           </a:p>
@@ -2517,7 +2517,7 @@
           <a:p>
             <a:fld id="{5BCAD085-E8A6-8845-BD4E-CB4CCA059FC4}" type="datetimeFigureOut">
               <a:rPr lang="en-US" smtClean="0"/>
-              <a:t>9/27/2026</a:t>
+              <a:t>10/2/2026</a:t>
             </a:fld>
             <a:endParaRPr lang="en-US"/>
           </a:p>
@@ -2728,7 +2728,7 @@
           <a:p>
             <a:fld id="{5BCAD085-E8A6-8845-BD4E-CB4CCA059FC4}" type="datetimeFigureOut">
               <a:rPr lang="en-US" smtClean="0"/>
-              <a:t>9/27/2026</a:t>
+              <a:t>10/2/2026</a:t>
             </a:fld>
             <a:endParaRPr lang="en-US"/>
           </a:p>
@@ -5567,6 +5567,7 @@
               </a:defRPr>
             </a:pPr>
             <a:r>
+              <a:rPr dirty="0"/>
               <a:t>TÀI LIỆU THAM KHẢO &amp; HƯỚNG DẪN CHẠY DỰ ÁN</a:t>
             </a:r>
           </a:p>
@@ -5577,23 +5578,111 @@
               </a:spcBef>
             </a:pPr>
             <a:r>
-              <a:rPr sz="1100" b="1">
+              <a:rPr sz="1100" b="1" dirty="0" err="1">
                 <a:solidFill>
                   <a:srgbClr val="007AFF"/>
                 </a:solidFill>
               </a:rPr>
-              <a:t>Tài liệu tham khảo:
+              <a:t>Tài</a:t>
+            </a:r>
+            <a:r>
+              <a:rPr sz="1100" b="1" dirty="0">
+                <a:solidFill>
+                  <a:srgbClr val="007AFF"/>
+                </a:solidFill>
+              </a:rPr>
+              <a:t> </a:t>
+            </a:r>
+            <a:r>
+              <a:rPr sz="1100" b="1" dirty="0" err="1">
+                <a:solidFill>
+                  <a:srgbClr val="007AFF"/>
+                </a:solidFill>
+              </a:rPr>
+              <a:t>liệu</a:t>
+            </a:r>
+            <a:r>
+              <a:rPr sz="1100" b="1" dirty="0">
+                <a:solidFill>
+                  <a:srgbClr val="007AFF"/>
+                </a:solidFill>
+              </a:rPr>
+              <a:t> </a:t>
+            </a:r>
+            <a:r>
+              <a:rPr sz="1100" b="1" dirty="0" err="1">
+                <a:solidFill>
+                  <a:srgbClr val="007AFF"/>
+                </a:solidFill>
+              </a:rPr>
+              <a:t>tham</a:t>
+            </a:r>
+            <a:r>
+              <a:rPr sz="1100" b="1" dirty="0">
+                <a:solidFill>
+                  <a:srgbClr val="007AFF"/>
+                </a:solidFill>
+              </a:rPr>
+              <a:t> </a:t>
+            </a:r>
+            <a:r>
+              <a:rPr sz="1100" b="1" dirty="0" err="1">
+                <a:solidFill>
+                  <a:srgbClr val="007AFF"/>
+                </a:solidFill>
+              </a:rPr>
+              <a:t>khảo</a:t>
+            </a:r>
+            <a:r>
+              <a:rPr sz="1100" b="1" dirty="0">
+                <a:solidFill>
+                  <a:srgbClr val="007AFF"/>
+                </a:solidFill>
+              </a:rPr>
+              <a:t>:
 </a:t>
             </a:r>
             <a:r>
-              <a:rPr sz="1050">
+              <a:rPr sz="1050" dirty="0">
                 <a:solidFill>
                   <a:srgbClr val="1E293B"/>
                 </a:solidFill>
               </a:rPr>
               <a:t>[1] Abhishek Sharma, Mobile Price Classification Dataset, Kaggle 2018.
-[2] Pedregosa et al., Scikit-learn: Machine Learning in Python, JMLR 2011.
-[3] FastAPI Framework Documentation &amp; Docker Compose Specification 2024.</a:t>
+[2] </a:t>
+            </a:r>
+            <a:r>
+              <a:rPr sz="1050" dirty="0" err="1">
+                <a:solidFill>
+                  <a:srgbClr val="1E293B"/>
+                </a:solidFill>
+              </a:rPr>
+              <a:t>Pedregosa</a:t>
+            </a:r>
+            <a:r>
+              <a:rPr sz="1050" dirty="0">
+                <a:solidFill>
+                  <a:srgbClr val="1E293B"/>
+                </a:solidFill>
+              </a:rPr>
+              <a:t> et al., Scikit-learn: Machine Learning in Python, JMLR 2011.
+[3] </a:t>
+            </a:r>
+            <a:r>
+              <a:rPr sz="1050" dirty="0" err="1">
+                <a:solidFill>
+                  <a:srgbClr val="1E293B"/>
+                </a:solidFill>
+              </a:rPr>
+              <a:t>FastAPI</a:t>
+            </a:r>
+            <a:r>
+              <a:rPr sz="1050" dirty="0">
+                <a:solidFill>
+                  <a:srgbClr val="1E293B"/>
+                </a:solidFill>
+              </a:rPr>
+              <a:t> Framework Documentation &amp; Docker Compose Specification 2024.</a:t>
             </a:r>
           </a:p>
           <a:p>
@@ -5603,23 +5692,239 @@
               </a:spcBef>
             </a:pPr>
             <a:r>
-              <a:rPr sz="1100" b="1">
+              <a:rPr sz="1100" b="1" dirty="0" err="1">
                 <a:solidFill>
                   <a:srgbClr val="007AFF"/>
                 </a:solidFill>
               </a:rPr>
-              <a:t>Hướng dẫn vận hành Docker 1 lệnh:
+              <a:t>Hướng</a:t>
+            </a:r>
+            <a:r>
+              <a:rPr sz="1100" b="1" dirty="0">
+                <a:solidFill>
+                  <a:srgbClr val="007AFF"/>
+                </a:solidFill>
+              </a:rPr>
+              <a:t> </a:t>
+            </a:r>
+            <a:r>
+              <a:rPr sz="1100" b="1" dirty="0" err="1">
+                <a:solidFill>
+                  <a:srgbClr val="007AFF"/>
+                </a:solidFill>
+              </a:rPr>
+              <a:t>dẫn</a:t>
+            </a:r>
+            <a:r>
+              <a:rPr sz="1100" b="1" dirty="0">
+                <a:solidFill>
+                  <a:srgbClr val="007AFF"/>
+                </a:solidFill>
+              </a:rPr>
+              <a:t> </a:t>
+            </a:r>
+            <a:r>
+              <a:rPr sz="1100" b="1" dirty="0" err="1">
+                <a:solidFill>
+                  <a:srgbClr val="007AFF"/>
+                </a:solidFill>
+              </a:rPr>
+              <a:t>vận</a:t>
+            </a:r>
+            <a:r>
+              <a:rPr sz="1100" b="1" dirty="0">
+                <a:solidFill>
+                  <a:srgbClr val="007AFF"/>
+                </a:solidFill>
+              </a:rPr>
+              <a:t> </a:t>
+            </a:r>
+            <a:r>
+              <a:rPr sz="1100" b="1" dirty="0" err="1">
+                <a:solidFill>
+                  <a:srgbClr val="007AFF"/>
+                </a:solidFill>
+              </a:rPr>
+              <a:t>hành</a:t>
+            </a:r>
+            <a:r>
+              <a:rPr sz="1100" b="1" dirty="0">
+                <a:solidFill>
+                  <a:srgbClr val="007AFF"/>
+                </a:solidFill>
+              </a:rPr>
+              <a:t> Docker 1 </a:t>
+            </a:r>
+            <a:r>
+              <a:rPr sz="1100" b="1" dirty="0" err="1">
+                <a:solidFill>
+                  <a:srgbClr val="007AFF"/>
+                </a:solidFill>
+              </a:rPr>
+              <a:t>lệnh</a:t>
+            </a:r>
+            <a:r>
+              <a:rPr sz="1100" b="1" dirty="0">
+                <a:solidFill>
+                  <a:srgbClr val="007AFF"/>
+                </a:solidFill>
+              </a:rPr>
+              <a:t>:
 </a:t>
             </a:r>
             <a:r>
-              <a:rPr sz="1050">
+              <a:rPr sz="1050" dirty="0">
                 <a:solidFill>
                   <a:srgbClr val="1E293B"/>
                 </a:solidFill>
               </a:rPr>
-              <a:t>1. Sao chép biến môi trường: `cp .env.example .env`
-2. Khởi chạy 4 container: `docker compose up --build`
-3. Truy cập Frontend `http://localhost:3000` | Backend Docs `http://localhost:8000/docs`</a:t>
+              <a:t>1. Sao </a:t>
+            </a:r>
+            <a:r>
+              <a:rPr sz="1050" dirty="0" err="1">
+                <a:solidFill>
+                  <a:srgbClr val="1E293B"/>
+                </a:solidFill>
+              </a:rPr>
+              <a:t>chép</a:t>
+            </a:r>
+            <a:r>
+              <a:rPr sz="1050" dirty="0">
+                <a:solidFill>
+                  <a:srgbClr val="1E293B"/>
+                </a:solidFill>
+              </a:rPr>
+              <a:t> </a:t>
+            </a:r>
+            <a:r>
+              <a:rPr sz="1050" dirty="0" err="1">
+                <a:solidFill>
+                  <a:srgbClr val="1E293B"/>
+                </a:solidFill>
+              </a:rPr>
+              <a:t>biến</a:t>
+            </a:r>
+            <a:r>
+              <a:rPr sz="1050" dirty="0">
+                <a:solidFill>
+                  <a:srgbClr val="1E293B"/>
+                </a:solidFill>
+              </a:rPr>
+              <a:t> </a:t>
+            </a:r>
+            <a:r>
+              <a:rPr sz="1050" dirty="0" err="1">
+                <a:solidFill>
+                  <a:srgbClr val="1E293B"/>
+                </a:solidFill>
+              </a:rPr>
+              <a:t>môi</a:t>
+            </a:r>
+            <a:r>
+              <a:rPr sz="1050" dirty="0">
+                <a:solidFill>
+                  <a:srgbClr val="1E293B"/>
+                </a:solidFill>
+              </a:rPr>
+              <a:t> </a:t>
+            </a:r>
+            <a:r>
+              <a:rPr sz="1050" dirty="0" err="1">
+                <a:solidFill>
+                  <a:srgbClr val="1E293B"/>
+                </a:solidFill>
+              </a:rPr>
+              <a:t>trường</a:t>
+            </a:r>
+            <a:r>
+              <a:rPr sz="1050" dirty="0">
+                <a:solidFill>
+                  <a:srgbClr val="1E293B"/>
+                </a:solidFill>
+              </a:rPr>
+              <a:t>: `cp .</a:t>
+            </a:r>
+            <a:r>
+              <a:rPr sz="1050" dirty="0" err="1">
+                <a:solidFill>
+                  <a:srgbClr val="1E293B"/>
+                </a:solidFill>
+              </a:rPr>
+              <a:t>env.example</a:t>
+            </a:r>
+            <a:r>
+              <a:rPr sz="1050" dirty="0">
+                <a:solidFill>
+                  <a:srgbClr val="1E293B"/>
+                </a:solidFill>
+              </a:rPr>
+              <a:t> .env`
+2. </a:t>
+            </a:r>
+            <a:r>
+              <a:rPr sz="1050" dirty="0" err="1">
+                <a:solidFill>
+                  <a:srgbClr val="1E293B"/>
+                </a:solidFill>
+              </a:rPr>
+              <a:t>Khởi</a:t>
+            </a:r>
+            <a:r>
+              <a:rPr sz="1050" dirty="0">
+                <a:solidFill>
+                  <a:srgbClr val="1E293B"/>
+                </a:solidFill>
+              </a:rPr>
+              <a:t> </a:t>
+            </a:r>
+            <a:r>
+              <a:rPr sz="1050" dirty="0" err="1">
+                <a:solidFill>
+                  <a:srgbClr val="1E293B"/>
+                </a:solidFill>
+              </a:rPr>
+              <a:t>chạy</a:t>
+            </a:r>
+            <a:r>
+              <a:rPr sz="1050" dirty="0">
+                <a:solidFill>
+                  <a:srgbClr val="1E293B"/>
+                </a:solidFill>
+              </a:rPr>
+              <a:t> 4 container: `docker compose up --build`
+3. </a:t>
+            </a:r>
+            <a:r>
+              <a:rPr sz="1050" dirty="0" err="1">
+                <a:solidFill>
+                  <a:srgbClr val="1E293B"/>
+                </a:solidFill>
+              </a:rPr>
+              <a:t>Truy</a:t>
+            </a:r>
+            <a:r>
+              <a:rPr sz="1050" dirty="0">
+                <a:solidFill>
+                  <a:srgbClr val="1E293B"/>
+                </a:solidFill>
+              </a:rPr>
+              <a:t> </a:t>
+            </a:r>
+            <a:r>
+              <a:rPr sz="1050" dirty="0" err="1">
+                <a:solidFill>
+                  <a:srgbClr val="1E293B"/>
+                </a:solidFill>
+              </a:rPr>
+              <a:t>cập</a:t>
+            </a:r>
+            <a:r>
+              <a:rPr sz="1050" dirty="0">
+                <a:solidFill>
+                  <a:srgbClr val="1E293B"/>
+                </a:solidFill>
+              </a:rPr>
+              <a:t> Frontend `http://localhost:3000` | Backend Docs `http://localhost:8000/docs`</a:t>
             </a:r>
           </a:p>
           <a:p>
@@ -5629,21 +5934,133 @@
               </a:spcBef>
             </a:pPr>
             <a:r>
-              <a:rPr sz="1100" b="1">
+              <a:rPr sz="1100" b="1" dirty="0" err="1">
                 <a:solidFill>
                   <a:srgbClr val="007AFF"/>
                 </a:solidFill>
               </a:rPr>
-              <a:t>Kiểm thử tự động Pytest:
+              <a:t>Kiểm</a:t>
+            </a:r>
+            <a:r>
+              <a:rPr sz="1100" b="1" dirty="0">
+                <a:solidFill>
+                  <a:srgbClr val="007AFF"/>
+                </a:solidFill>
+              </a:rPr>
+              <a:t> </a:t>
+            </a:r>
+            <a:r>
+              <a:rPr sz="1100" b="1" dirty="0" err="1">
+                <a:solidFill>
+                  <a:srgbClr val="007AFF"/>
+                </a:solidFill>
+              </a:rPr>
+              <a:t>thử</a:t>
+            </a:r>
+            <a:r>
+              <a:rPr sz="1100" b="1" dirty="0">
+                <a:solidFill>
+                  <a:srgbClr val="007AFF"/>
+                </a:solidFill>
+              </a:rPr>
+              <a:t> </a:t>
+            </a:r>
+            <a:r>
+              <a:rPr sz="1100" b="1" dirty="0" err="1">
+                <a:solidFill>
+                  <a:srgbClr val="007AFF"/>
+                </a:solidFill>
+              </a:rPr>
+              <a:t>tự</a:t>
+            </a:r>
+            <a:r>
+              <a:rPr sz="1100" b="1" dirty="0">
+                <a:solidFill>
+                  <a:srgbClr val="007AFF"/>
+                </a:solidFill>
+              </a:rPr>
+              <a:t> </a:t>
+            </a:r>
+            <a:r>
+              <a:rPr sz="1100" b="1" dirty="0" err="1">
+                <a:solidFill>
+                  <a:srgbClr val="007AFF"/>
+                </a:solidFill>
+              </a:rPr>
+              <a:t>động</a:t>
+            </a:r>
+            <a:r>
+              <a:rPr sz="1100" b="1" dirty="0">
+                <a:solidFill>
+                  <a:srgbClr val="007AFF"/>
+                </a:solidFill>
+              </a:rPr>
+              <a:t> </a:t>
+            </a:r>
+            <a:r>
+              <a:rPr sz="1100" b="1" dirty="0" err="1">
+                <a:solidFill>
+                  <a:srgbClr val="007AFF"/>
+                </a:solidFill>
+              </a:rPr>
+              <a:t>Pytest</a:t>
+            </a:r>
+            <a:r>
+              <a:rPr sz="1100" b="1" dirty="0">
+                <a:solidFill>
+                  <a:srgbClr val="007AFF"/>
+                </a:solidFill>
+              </a:rPr>
+              <a:t>:
 </a:t>
             </a:r>
             <a:r>
-              <a:rPr sz="1050">
+              <a:rPr sz="1050" dirty="0" err="1">
                 <a:solidFill>
                   <a:srgbClr val="1E293B"/>
                 </a:solidFill>
               </a:rPr>
-              <a:t>Chạy bộ 12 unit test cases: `pytest app/backend/tests -v`</a:t>
+              <a:t>Chạy</a:t>
+            </a:r>
+            <a:r>
+              <a:rPr sz="1050" dirty="0">
+                <a:solidFill>
+                  <a:srgbClr val="1E293B"/>
+                </a:solidFill>
+              </a:rPr>
+              <a:t> </a:t>
+            </a:r>
+            <a:r>
+              <a:rPr sz="1050" dirty="0" err="1">
+                <a:solidFill>
+                  <a:srgbClr val="1E293B"/>
+                </a:solidFill>
+              </a:rPr>
+              <a:t>bộ</a:t>
+            </a:r>
+            <a:r>
+              <a:rPr sz="1050" dirty="0">
+                <a:solidFill>
+                  <a:srgbClr val="1E293B"/>
+                </a:solidFill>
+              </a:rPr>
+              <a:t> 12 unit test cases: `</a:t>
+            </a:r>
+            <a:r>
+              <a:rPr sz="1050" dirty="0" err="1">
+                <a:solidFill>
+                  <a:srgbClr val="1E293B"/>
+                </a:solidFill>
+              </a:rPr>
+              <a:t>pytest</a:t>
+            </a:r>
+            <a:r>
+              <a:rPr sz="1050" dirty="0">
+                <a:solidFill>
+                  <a:srgbClr val="1E293B"/>
+                </a:solidFill>
+              </a:rPr>
+              <a:t> app/backend/tests -v`</a:t>
             </a:r>
           </a:p>
           <a:p>
@@ -5658,6 +6075,7 @@
               </a:defRPr>
             </a:pPr>
             <a:r>
+              <a:rPr dirty="0"/>
               <a:t>XIN CHÂN THÀNH CẢM ƠN THẦY CÔ VÀ CÁC BẠN! — Q &amp; A</a:t>
             </a:r>
           </a:p>
@@ -7546,7 +7964,7 @@
         <p:spPr>
           <a:xfrm>
             <a:off x="6400800" y="1645920"/>
-            <a:ext cx="4846320" cy="1920240"/>
+            <a:ext cx="4846320" cy="836126"/>
           </a:xfrm>
           <a:prstGeom prst="rect">
             <a:avLst/>
@@ -7567,7 +7985,28 @@
               </a:defRPr>
             </a:pPr>
             <a:r>
-              <a:t>Bước 2: StandardScaler (Chống Data Leakage)</a:t>
+              <a:rPr dirty="0" err="1"/>
+              <a:t>Bước</a:t>
+            </a:r>
+            <a:r>
+              <a:rPr dirty="0"/>
+              <a:t> 2: </a:t>
+            </a:r>
+            <a:r>
+              <a:rPr dirty="0" err="1"/>
+              <a:t>StandardScaler</a:t>
+            </a:r>
+            <a:r>
+              <a:rPr dirty="0"/>
+              <a:t> (</a:t>
+            </a:r>
+            <a:r>
+              <a:rPr dirty="0" err="1"/>
+              <a:t>Chống</a:t>
+            </a:r>
+            <a:r>
+              <a:rPr dirty="0"/>
+              <a:t> Data Leakage)</a:t>
             </a:r>
           </a:p>
           <a:p>
@@ -7582,11 +8021,213 @@
               </a:defRPr>
             </a:pPr>
             <a:r>
-              <a:t>Tính toán trung bình ($\mu$) và độ lệch chuẩn ($\sigma$) DUY NHẤT trên tập Train (`scaler.fit(X_train)`).</a:t>
-            </a:r>
-            <a:br/>
-            <a:r>
-              <a:t>Sau đó mới biến đổi `transform` sang tập Test. Tuyệt đối không fit trên tập Test.</a:t>
+              <a:rPr dirty="0" err="1"/>
+              <a:t>Tính</a:t>
+            </a:r>
+            <a:r>
+              <a:rPr dirty="0"/>
+              <a:t> </a:t>
+            </a:r>
+            <a:r>
+              <a:rPr dirty="0" err="1"/>
+              <a:t>toán</a:t>
+            </a:r>
+            <a:r>
+              <a:rPr dirty="0"/>
+              <a:t> </a:t>
+            </a:r>
+            <a:r>
+              <a:rPr dirty="0" err="1"/>
+              <a:t>trung</a:t>
+            </a:r>
+            <a:r>
+              <a:rPr dirty="0"/>
+              <a:t> </a:t>
+            </a:r>
+            <a:r>
+              <a:rPr dirty="0" err="1"/>
+              <a:t>bình</a:t>
+            </a:r>
+            <a:r>
+              <a:rPr dirty="0"/>
+              <a:t> (</a:t>
+            </a:r>
+            <a:r>
+              <a:rPr lang="en-US" sz="1050" dirty="0">
+                <a:effectLst/>
+                <a:ea typeface="Times New Roman" panose="02020603050405020304" pitchFamily="18" charset="0"/>
+              </a:rPr>
+              <a:t>μ)</a:t>
+            </a:r>
+            <a:r>
+              <a:rPr sz="1050" dirty="0"/>
+              <a:t> </a:t>
+            </a:r>
+            <a:r>
+              <a:rPr dirty="0" err="1"/>
+              <a:t>và</a:t>
+            </a:r>
+            <a:r>
+              <a:rPr dirty="0"/>
+              <a:t> </a:t>
+            </a:r>
+            <a:r>
+              <a:rPr dirty="0" err="1"/>
+              <a:t>độ</a:t>
+            </a:r>
+            <a:r>
+              <a:rPr dirty="0"/>
+              <a:t> </a:t>
+            </a:r>
+            <a:r>
+              <a:rPr dirty="0" err="1"/>
+              <a:t>lệch</a:t>
+            </a:r>
+            <a:r>
+              <a:rPr dirty="0"/>
+              <a:t> </a:t>
+            </a:r>
+            <a:r>
+              <a:rPr dirty="0" err="1"/>
+              <a:t>chuẩn</a:t>
+            </a:r>
+            <a:r>
+              <a:rPr dirty="0"/>
+              <a:t> </a:t>
+            </a:r>
+            <a:r>
+              <a:rPr lang="en-US" sz="1050" dirty="0"/>
+              <a:t>(</a:t>
+            </a:r>
+            <a:r>
+              <a:rPr lang="en-US" sz="1050" dirty="0">
+                <a:effectLst/>
+                <a:ea typeface="Times New Roman" panose="02020603050405020304" pitchFamily="18" charset="0"/>
+              </a:rPr>
+              <a:t>σ) </a:t>
+            </a:r>
+            <a:r>
+              <a:rPr dirty="0"/>
+              <a:t>DUY NHẤT </a:t>
+            </a:r>
+            <a:r>
+              <a:rPr dirty="0" err="1"/>
+              <a:t>trên</a:t>
+            </a:r>
+            <a:r>
+              <a:rPr dirty="0"/>
+              <a:t> </a:t>
+            </a:r>
+            <a:r>
+              <a:rPr dirty="0" err="1"/>
+              <a:t>tập</a:t>
+            </a:r>
+            <a:r>
+              <a:rPr dirty="0"/>
+              <a:t> Train (`</a:t>
+            </a:r>
+            <a:r>
+              <a:rPr dirty="0" err="1"/>
+              <a:t>scaler.fit</a:t>
+            </a:r>
+            <a:r>
+              <a:rPr dirty="0"/>
+              <a:t>(</a:t>
+            </a:r>
+            <a:r>
+              <a:rPr dirty="0" err="1"/>
+              <a:t>X_train</a:t>
+            </a:r>
+            <a:r>
+              <a:rPr dirty="0"/>
+              <a:t>)`).</a:t>
+            </a:r>
+            <a:br>
+              <a:rPr dirty="0"/>
+            </a:br>
+            <a:r>
+              <a:rPr dirty="0"/>
+              <a:t>Sau </a:t>
+            </a:r>
+            <a:r>
+              <a:rPr dirty="0" err="1"/>
+              <a:t>đó</a:t>
+            </a:r>
+            <a:r>
+              <a:rPr dirty="0"/>
+              <a:t> </a:t>
+            </a:r>
+            <a:r>
+              <a:rPr dirty="0" err="1"/>
+              <a:t>mới</a:t>
+            </a:r>
+            <a:r>
+              <a:rPr dirty="0"/>
+              <a:t> </a:t>
+            </a:r>
+            <a:r>
+              <a:rPr dirty="0" err="1"/>
+              <a:t>biến</a:t>
+            </a:r>
+            <a:r>
+              <a:rPr dirty="0"/>
+              <a:t> </a:t>
+            </a:r>
+            <a:r>
+              <a:rPr dirty="0" err="1"/>
+              <a:t>đổi</a:t>
+            </a:r>
+            <a:r>
+              <a:rPr dirty="0"/>
+              <a:t> `transform` sang </a:t>
+            </a:r>
+            <a:r>
+              <a:rPr dirty="0" err="1"/>
+              <a:t>tập</a:t>
+            </a:r>
+            <a:r>
+              <a:rPr dirty="0"/>
+              <a:t> Test. </a:t>
+            </a:r>
+            <a:r>
+              <a:rPr dirty="0" err="1"/>
+              <a:t>Tuyệt</a:t>
+            </a:r>
+            <a:r>
+              <a:rPr dirty="0"/>
+              <a:t> </a:t>
+            </a:r>
+            <a:r>
+              <a:rPr dirty="0" err="1"/>
+              <a:t>đối</a:t>
+            </a:r>
+            <a:r>
+              <a:rPr dirty="0"/>
+              <a:t> </a:t>
+            </a:r>
+            <a:r>
+              <a:rPr dirty="0" err="1"/>
+              <a:t>không</a:t>
+            </a:r>
+            <a:r>
+              <a:rPr dirty="0"/>
+              <a:t> fit </a:t>
+            </a:r>
+            <a:r>
+              <a:rPr dirty="0" err="1"/>
+              <a:t>trên</a:t>
+            </a:r>
+            <a:r>
+              <a:rPr dirty="0"/>
+              <a:t> </a:t>
+            </a:r>
+            <a:r>
+              <a:rPr dirty="0" err="1"/>
+              <a:t>tập</a:t>
+            </a:r>
+            <a:r>
+              <a:rPr dirty="0"/>
+              <a:t> Test.</a:t>
             </a:r>
           </a:p>
         </p:txBody>
@@ -7987,7 +8628,7 @@
         <p:spPr>
           <a:xfrm>
             <a:off x="914400" y="1600200"/>
-            <a:ext cx="4846320" cy="2011680"/>
+            <a:ext cx="4846320" cy="1136208"/>
           </a:xfrm>
           <a:prstGeom prst="rect">
             <a:avLst/>
@@ -8008,6 +8649,7 @@
               </a:defRPr>
             </a:pPr>
             <a:r>
+              <a:rPr dirty="0"/>
               <a:t>🏆 1. Logistic Regression (Multinomial)</a:t>
             </a:r>
           </a:p>
@@ -8023,15 +8665,391 @@
               </a:defRPr>
             </a:pPr>
             <a:r>
-              <a:t>• Nguyên lý: Hàm Softmax ước lượng xác suất 4 lớp $P(y=k|X) = \frac{e^{w_k^T X + b_k}}{\sum e^{w_j^T X + b_j}}$.</a:t>
-            </a:r>
-            <a:br/>
-            <a:r>
-              <a:t>• Siêu tham số thử nghiệm: $C \in [0.01, 0.1, 1.0, 10.0, 100.0]$, solver='lbfgs', max_iter=1000.</a:t>
-            </a:r>
-            <a:br/>
-            <a:r>
-              <a:t>• Kết quả tinh chỉnh: $C = 10.0$ cho hiệu năng tối ưu nhất (5-Fold CV Score = 96.31%).</a:t>
+              <a:rPr dirty="0"/>
+              <a:t>• </a:t>
+            </a:r>
+            <a:r>
+              <a:rPr dirty="0" err="1"/>
+              <a:t>Nguyên</a:t>
+            </a:r>
+            <a:r>
+              <a:rPr dirty="0"/>
+              <a:t> </a:t>
+            </a:r>
+            <a:r>
+              <a:rPr dirty="0" err="1"/>
+              <a:t>lý</a:t>
+            </a:r>
+            <a:r>
+              <a:rPr dirty="0"/>
+              <a:t>: </a:t>
+            </a:r>
+            <a:r>
+              <a:rPr dirty="0" err="1"/>
+              <a:t>Hàm</a:t>
+            </a:r>
+            <a:r>
+              <a:rPr dirty="0"/>
+              <a:t> </a:t>
+            </a:r>
+            <a:r>
+              <a:rPr dirty="0" err="1"/>
+              <a:t>Softmax</a:t>
+            </a:r>
+            <a:r>
+              <a:rPr dirty="0"/>
+              <a:t> </a:t>
+            </a:r>
+            <a:r>
+              <a:rPr dirty="0" err="1"/>
+              <a:t>ước</a:t>
+            </a:r>
+            <a:r>
+              <a:rPr dirty="0"/>
+              <a:t> </a:t>
+            </a:r>
+            <a:r>
+              <a:rPr dirty="0" err="1"/>
+              <a:t>lượng</a:t>
+            </a:r>
+            <a:r>
+              <a:rPr dirty="0"/>
+              <a:t> </a:t>
+            </a:r>
+            <a:r>
+              <a:rPr dirty="0" err="1"/>
+              <a:t>xác</a:t>
+            </a:r>
+            <a:r>
+              <a:rPr dirty="0"/>
+              <a:t> </a:t>
+            </a:r>
+            <a:r>
+              <a:rPr dirty="0" err="1"/>
+              <a:t>suất</a:t>
+            </a:r>
+            <a:r>
+              <a:rPr dirty="0"/>
+              <a:t> 4 </a:t>
+            </a:r>
+            <a:r>
+              <a:rPr dirty="0" err="1"/>
+              <a:t>lớp</a:t>
+            </a:r>
+            <a:r>
+              <a:rPr dirty="0"/>
+              <a:t> </a:t>
+            </a:r>
+            <a:r>
+              <a:rPr lang="en-US" sz="1050" dirty="0">
+                <a:effectLst/>
+                <a:ea typeface="Times New Roman" panose="02020603050405020304" pitchFamily="18" charset="0"/>
+              </a:rPr>
+              <a:t>P(y = k | X) = exp(</a:t>
+            </a:r>
+            <a:r>
+              <a:rPr lang="en-US" sz="1050" dirty="0" err="1">
+                <a:effectLst/>
+                <a:ea typeface="Times New Roman" panose="02020603050405020304" pitchFamily="18" charset="0"/>
+              </a:rPr>
+              <a:t>w</a:t>
+            </a:r>
+            <a:r>
+              <a:rPr lang="en-US" sz="1050" baseline="-25000" dirty="0" err="1">
+                <a:effectLst/>
+                <a:ea typeface="Times New Roman" panose="02020603050405020304" pitchFamily="18" charset="0"/>
+              </a:rPr>
+              <a:t>k</a:t>
+            </a:r>
+            <a:r>
+              <a:rPr lang="en-US" sz="1050" baseline="30000" dirty="0" err="1">
+                <a:effectLst/>
+                <a:ea typeface="Times New Roman" panose="02020603050405020304" pitchFamily="18" charset="0"/>
+              </a:rPr>
+              <a:t>T</a:t>
+            </a:r>
+            <a:r>
+              <a:rPr lang="en-US" sz="1050" dirty="0" err="1">
+                <a:effectLst/>
+                <a:ea typeface="Times New Roman" panose="02020603050405020304" pitchFamily="18" charset="0"/>
+              </a:rPr>
+              <a:t>X</a:t>
+            </a:r>
+            <a:r>
+              <a:rPr lang="en-US" sz="1050" dirty="0">
+                <a:effectLst/>
+                <a:ea typeface="Times New Roman" panose="02020603050405020304" pitchFamily="18" charset="0"/>
+              </a:rPr>
+              <a:t> + b</a:t>
+            </a:r>
+            <a:r>
+              <a:rPr lang="en-US" sz="1050" baseline="-25000" dirty="0">
+                <a:effectLst/>
+                <a:ea typeface="Times New Roman" panose="02020603050405020304" pitchFamily="18" charset="0"/>
+              </a:rPr>
+              <a:t>k</a:t>
+            </a:r>
+            <a:r>
+              <a:rPr lang="en-US" sz="1050" dirty="0">
+                <a:effectLst/>
+                <a:ea typeface="Times New Roman" panose="02020603050405020304" pitchFamily="18" charset="0"/>
+              </a:rPr>
+              <a:t>) / </a:t>
+            </a:r>
+            <a:r>
+              <a:rPr lang="en-US" sz="1050" dirty="0" err="1">
+                <a:effectLst/>
+                <a:ea typeface="Times New Roman" panose="02020603050405020304" pitchFamily="18" charset="0"/>
+              </a:rPr>
+              <a:t>Σ</a:t>
+            </a:r>
+            <a:r>
+              <a:rPr lang="en-US" sz="1050" baseline="-25000" dirty="0" err="1">
+                <a:effectLst/>
+                <a:ea typeface="Times New Roman" panose="02020603050405020304" pitchFamily="18" charset="0"/>
+              </a:rPr>
+              <a:t>j</a:t>
+            </a:r>
+            <a:r>
+              <a:rPr lang="en-US" sz="1050" baseline="-25000" dirty="0">
+                <a:effectLst/>
+                <a:ea typeface="Times New Roman" panose="02020603050405020304" pitchFamily="18" charset="0"/>
+              </a:rPr>
+              <a:t>=0</a:t>
+            </a:r>
+            <a:r>
+              <a:rPr lang="en-US" sz="1050" baseline="30000" dirty="0">
+                <a:effectLst/>
+                <a:ea typeface="Times New Roman" panose="02020603050405020304" pitchFamily="18" charset="0"/>
+              </a:rPr>
+              <a:t>3</a:t>
+            </a:r>
+            <a:r>
+              <a:rPr lang="en-US" sz="1050" dirty="0">
+                <a:effectLst/>
+                <a:ea typeface="Times New Roman" panose="02020603050405020304" pitchFamily="18" charset="0"/>
+              </a:rPr>
+              <a:t> exp(</a:t>
+            </a:r>
+            <a:r>
+              <a:rPr lang="en-US" sz="1050" dirty="0" err="1">
+                <a:effectLst/>
+                <a:ea typeface="Times New Roman" panose="02020603050405020304" pitchFamily="18" charset="0"/>
+              </a:rPr>
+              <a:t>w</a:t>
+            </a:r>
+            <a:r>
+              <a:rPr lang="en-US" sz="1050" baseline="-25000" dirty="0" err="1">
+                <a:effectLst/>
+                <a:ea typeface="Times New Roman" panose="02020603050405020304" pitchFamily="18" charset="0"/>
+              </a:rPr>
+              <a:t>j</a:t>
+            </a:r>
+            <a:r>
+              <a:rPr lang="en-US" sz="1050" baseline="30000" dirty="0" err="1">
+                <a:effectLst/>
+                <a:ea typeface="Times New Roman" panose="02020603050405020304" pitchFamily="18" charset="0"/>
+              </a:rPr>
+              <a:t>T</a:t>
+            </a:r>
+            <a:r>
+              <a:rPr lang="en-US" sz="1050" dirty="0" err="1">
+                <a:effectLst/>
+                <a:ea typeface="Times New Roman" panose="02020603050405020304" pitchFamily="18" charset="0"/>
+              </a:rPr>
+              <a:t>X</a:t>
+            </a:r>
+            <a:r>
+              <a:rPr lang="en-US" sz="1050" dirty="0">
+                <a:effectLst/>
+                <a:ea typeface="Times New Roman" panose="02020603050405020304" pitchFamily="18" charset="0"/>
+              </a:rPr>
+              <a:t> + </a:t>
+            </a:r>
+            <a:r>
+              <a:rPr lang="en-US" sz="1050" dirty="0" err="1">
+                <a:effectLst/>
+                <a:ea typeface="Times New Roman" panose="02020603050405020304" pitchFamily="18" charset="0"/>
+              </a:rPr>
+              <a:t>b</a:t>
+            </a:r>
+            <a:r>
+              <a:rPr lang="en-US" sz="1050" baseline="-25000" dirty="0" err="1">
+                <a:effectLst/>
+                <a:ea typeface="Times New Roman" panose="02020603050405020304" pitchFamily="18" charset="0"/>
+              </a:rPr>
+              <a:t>j</a:t>
+            </a:r>
+            <a:r>
+              <a:rPr lang="en-US" sz="1050" dirty="0">
+                <a:effectLst/>
+                <a:ea typeface="Times New Roman" panose="02020603050405020304" pitchFamily="18" charset="0"/>
+              </a:rPr>
+              <a:t>) </a:t>
+            </a:r>
+            <a:br>
+              <a:rPr dirty="0"/>
+            </a:br>
+            <a:r>
+              <a:rPr dirty="0"/>
+              <a:t>• </a:t>
+            </a:r>
+            <a:r>
+              <a:rPr dirty="0" err="1"/>
+              <a:t>Siêu</a:t>
+            </a:r>
+            <a:r>
+              <a:rPr dirty="0"/>
+              <a:t> </a:t>
+            </a:r>
+            <a:r>
+              <a:rPr dirty="0" err="1"/>
+              <a:t>tham</a:t>
+            </a:r>
+            <a:r>
+              <a:rPr dirty="0"/>
+              <a:t> </a:t>
+            </a:r>
+            <a:r>
+              <a:rPr dirty="0" err="1"/>
+              <a:t>số</a:t>
+            </a:r>
+            <a:r>
+              <a:rPr dirty="0"/>
+              <a:t> </a:t>
+            </a:r>
+            <a:r>
+              <a:rPr dirty="0" err="1"/>
+              <a:t>thử</a:t>
+            </a:r>
+            <a:r>
+              <a:rPr dirty="0"/>
+              <a:t> </a:t>
+            </a:r>
+            <a:r>
+              <a:rPr dirty="0" err="1"/>
+              <a:t>nghiệm</a:t>
+            </a:r>
+            <a:r>
+              <a:rPr dirty="0"/>
+              <a:t>: C </a:t>
+            </a:r>
+            <a:r>
+              <a:rPr lang="en-US" sz="1050" dirty="0">
+                <a:solidFill>
+                  <a:srgbClr val="000000"/>
+                </a:solidFill>
+                <a:effectLst/>
+                <a:ea typeface="Times New Roman" panose="02020603050405020304" pitchFamily="18" charset="0"/>
+              </a:rPr>
+              <a:t>∈</a:t>
+            </a:r>
+            <a:r>
+              <a:rPr dirty="0"/>
+              <a:t>[0.01, 0.1, 1.0, 10.0, 100.0], solver='</a:t>
+            </a:r>
+            <a:r>
+              <a:rPr dirty="0" err="1"/>
+              <a:t>lbfgs</a:t>
+            </a:r>
+            <a:r>
+              <a:rPr dirty="0"/>
+              <a:t>', </a:t>
+            </a:r>
+            <a:r>
+              <a:rPr dirty="0" err="1"/>
+              <a:t>max_iter</a:t>
+            </a:r>
+            <a:r>
+              <a:rPr dirty="0"/>
+              <a:t>=1000.</a:t>
+            </a:r>
+            <a:br>
+              <a:rPr dirty="0"/>
+            </a:br>
+            <a:r>
+              <a:rPr dirty="0"/>
+              <a:t>• </a:t>
+            </a:r>
+            <a:r>
+              <a:rPr dirty="0" err="1"/>
+              <a:t>Kết</a:t>
+            </a:r>
+            <a:r>
+              <a:rPr dirty="0"/>
+              <a:t> </a:t>
+            </a:r>
+            <a:r>
+              <a:rPr dirty="0" err="1"/>
+              <a:t>quả</a:t>
+            </a:r>
+            <a:r>
+              <a:rPr dirty="0"/>
+              <a:t> </a:t>
+            </a:r>
+            <a:r>
+              <a:rPr dirty="0" err="1"/>
+              <a:t>tinh</a:t>
+            </a:r>
+            <a:r>
+              <a:rPr dirty="0"/>
+              <a:t> </a:t>
+            </a:r>
+            <a:r>
+              <a:rPr dirty="0" err="1"/>
+              <a:t>chỉnh</a:t>
+            </a:r>
+            <a:r>
+              <a:rPr dirty="0"/>
+              <a:t>: C = 10.0 </a:t>
+            </a:r>
+            <a:r>
+              <a:rPr dirty="0" err="1"/>
+              <a:t>cho</a:t>
+            </a:r>
+            <a:r>
+              <a:rPr dirty="0"/>
+              <a:t> </a:t>
+            </a:r>
+            <a:r>
+              <a:rPr dirty="0" err="1"/>
+              <a:t>hiệu</a:t>
+            </a:r>
+            <a:r>
+              <a:rPr dirty="0"/>
+              <a:t> </a:t>
+            </a:r>
+            <a:r>
+              <a:rPr dirty="0" err="1"/>
+              <a:t>năng</a:t>
+            </a:r>
+            <a:r>
+              <a:rPr dirty="0"/>
+              <a:t> </a:t>
+            </a:r>
+            <a:r>
+              <a:rPr dirty="0" err="1"/>
+              <a:t>tối</a:t>
+            </a:r>
+            <a:r>
+              <a:rPr dirty="0"/>
+              <a:t> </a:t>
+            </a:r>
+            <a:r>
+              <a:rPr dirty="0" err="1"/>
+              <a:t>ưu</a:t>
+            </a:r>
+            <a:r>
+              <a:rPr dirty="0"/>
+              <a:t> </a:t>
+            </a:r>
+            <a:r>
+              <a:rPr dirty="0" err="1"/>
+              <a:t>nhất</a:t>
+            </a:r>
+            <a:r>
+              <a:rPr dirty="0"/>
+              <a:t> (5-Fold CV Score = 96.31%).</a:t>
             </a:r>
           </a:p>
         </p:txBody>
@@ -8091,7 +9109,7 @@
         <p:spPr>
           <a:xfrm>
             <a:off x="6400800" y="1600200"/>
-            <a:ext cx="4846320" cy="2011680"/>
+            <a:ext cx="4846320" cy="1136208"/>
           </a:xfrm>
           <a:prstGeom prst="rect">
             <a:avLst/>
@@ -8112,7 +9130,16 @@
               </a:defRPr>
             </a:pPr>
             <a:r>
-              <a:t>🥈 2. Support Vector Machine (SVC)</a:t>
+              <a:rPr dirty="0"/>
+              <a:t>🥈 2. Support Vector Machine (SV</a:t>
+            </a:r>
+            <a:r>
+              <a:rPr lang="en-US" dirty="0"/>
+              <a:t>M</a:t>
+            </a:r>
+            <a:r>
+              <a:rPr dirty="0"/>
+              <a:t>)</a:t>
             </a:r>
           </a:p>
           <a:p>
@@ -8127,15 +9154,276 @@
               </a:defRPr>
             </a:pPr>
             <a:r>
-              <a:t>• Nguyên lý: Tìm kiếm siêu phẳng tối ưu (Optimal Hyperplane) tối đa hóa khoảng cách biên (Margin).</a:t>
-            </a:r>
-            <a:br/>
-            <a:r>
-              <a:t>• Siêu tham số thử nghiệm: $C \in [0.1, 1.0, 5.0, 10.0]$, kernel='linear' &amp; 'rbf'.</a:t>
-            </a:r>
-            <a:br/>
-            <a:r>
-              <a:t>• Kết quả tinh chỉnh: Linear Kernel với $C = 5.0$ cho hiệu năng rất tốt (5-Fold CV Score = 95.81%).</a:t>
+              <a:rPr dirty="0"/>
+              <a:t>• </a:t>
+            </a:r>
+            <a:r>
+              <a:rPr dirty="0" err="1"/>
+              <a:t>Nguyên</a:t>
+            </a:r>
+            <a:r>
+              <a:rPr dirty="0"/>
+              <a:t> </a:t>
+            </a:r>
+            <a:r>
+              <a:rPr dirty="0" err="1"/>
+              <a:t>lý</a:t>
+            </a:r>
+            <a:r>
+              <a:rPr dirty="0"/>
+              <a:t>: </a:t>
+            </a:r>
+            <a:r>
+              <a:rPr dirty="0" err="1"/>
+              <a:t>Tìm</a:t>
+            </a:r>
+            <a:r>
+              <a:rPr dirty="0"/>
+              <a:t> </a:t>
+            </a:r>
+            <a:r>
+              <a:rPr dirty="0" err="1"/>
+              <a:t>kiếm</a:t>
+            </a:r>
+            <a:r>
+              <a:rPr dirty="0"/>
+              <a:t> </a:t>
+            </a:r>
+            <a:r>
+              <a:rPr dirty="0" err="1"/>
+              <a:t>siêu</a:t>
+            </a:r>
+            <a:r>
+              <a:rPr dirty="0"/>
+              <a:t> </a:t>
+            </a:r>
+            <a:r>
+              <a:rPr dirty="0" err="1"/>
+              <a:t>phẳng</a:t>
+            </a:r>
+            <a:r>
+              <a:rPr dirty="0"/>
+              <a:t> </a:t>
+            </a:r>
+            <a:r>
+              <a:rPr dirty="0" err="1"/>
+              <a:t>tối</a:t>
+            </a:r>
+            <a:r>
+              <a:rPr dirty="0"/>
+              <a:t> </a:t>
+            </a:r>
+            <a:r>
+              <a:rPr dirty="0" err="1"/>
+              <a:t>ưu</a:t>
+            </a:r>
+            <a:r>
+              <a:rPr dirty="0"/>
+              <a:t> (Optimal Hyperplane) </a:t>
+            </a:r>
+            <a:r>
+              <a:rPr dirty="0" err="1"/>
+              <a:t>tối</a:t>
+            </a:r>
+            <a:r>
+              <a:rPr dirty="0"/>
+              <a:t> </a:t>
+            </a:r>
+            <a:r>
+              <a:rPr dirty="0" err="1"/>
+              <a:t>đa</a:t>
+            </a:r>
+            <a:r>
+              <a:rPr dirty="0"/>
+              <a:t> </a:t>
+            </a:r>
+            <a:r>
+              <a:rPr dirty="0" err="1"/>
+              <a:t>hóa</a:t>
+            </a:r>
+            <a:r>
+              <a:rPr dirty="0"/>
+              <a:t> </a:t>
+            </a:r>
+            <a:r>
+              <a:rPr dirty="0" err="1"/>
+              <a:t>khoảng</a:t>
+            </a:r>
+            <a:r>
+              <a:rPr dirty="0"/>
+              <a:t> </a:t>
+            </a:r>
+            <a:r>
+              <a:rPr dirty="0" err="1"/>
+              <a:t>cách</a:t>
+            </a:r>
+            <a:r>
+              <a:rPr dirty="0"/>
+              <a:t> </a:t>
+            </a:r>
+            <a:r>
+              <a:rPr dirty="0" err="1"/>
+              <a:t>biên</a:t>
+            </a:r>
+            <a:r>
+              <a:rPr dirty="0"/>
+              <a:t> (Margin).</a:t>
+            </a:r>
+            <a:br>
+              <a:rPr dirty="0"/>
+            </a:br>
+            <a:r>
+              <a:rPr dirty="0"/>
+              <a:t>• </a:t>
+            </a:r>
+            <a:r>
+              <a:rPr dirty="0" err="1"/>
+              <a:t>Siêu</a:t>
+            </a:r>
+            <a:r>
+              <a:rPr dirty="0"/>
+              <a:t> </a:t>
+            </a:r>
+            <a:r>
+              <a:rPr dirty="0" err="1"/>
+              <a:t>tham</a:t>
+            </a:r>
+            <a:r>
+              <a:rPr dirty="0"/>
+              <a:t> </a:t>
+            </a:r>
+            <a:r>
+              <a:rPr dirty="0" err="1"/>
+              <a:t>số</a:t>
+            </a:r>
+            <a:r>
+              <a:rPr dirty="0"/>
+              <a:t> </a:t>
+            </a:r>
+            <a:r>
+              <a:rPr dirty="0" err="1"/>
+              <a:t>thử</a:t>
+            </a:r>
+            <a:r>
+              <a:rPr dirty="0"/>
+              <a:t> </a:t>
+            </a:r>
+            <a:r>
+              <a:rPr dirty="0" err="1"/>
+              <a:t>nghiệm</a:t>
+            </a:r>
+            <a:r>
+              <a:rPr dirty="0"/>
+              <a:t>: C </a:t>
+            </a:r>
+            <a:r>
+              <a:rPr lang="en-US" sz="1050" dirty="0">
+                <a:solidFill>
+                  <a:srgbClr val="000000"/>
+                </a:solidFill>
+                <a:effectLst/>
+                <a:ea typeface="Times New Roman" panose="02020603050405020304" pitchFamily="18" charset="0"/>
+              </a:rPr>
+              <a:t>∈</a:t>
+            </a:r>
+            <a:r>
+              <a:rPr dirty="0"/>
+              <a:t>[0.1, 1.0, 5.0, 10.0], kernel='linear' &amp; '</a:t>
+            </a:r>
+            <a:r>
+              <a:rPr dirty="0" err="1"/>
+              <a:t>rbf</a:t>
+            </a:r>
+            <a:r>
+              <a:rPr dirty="0"/>
+              <a:t>'.</a:t>
+            </a:r>
+            <a:br>
+              <a:rPr dirty="0"/>
+            </a:br>
+            <a:r>
+              <a:rPr dirty="0"/>
+              <a:t>• </a:t>
+            </a:r>
+            <a:r>
+              <a:rPr dirty="0" err="1"/>
+              <a:t>Kết</a:t>
+            </a:r>
+            <a:r>
+              <a:rPr dirty="0"/>
+              <a:t> </a:t>
+            </a:r>
+            <a:r>
+              <a:rPr dirty="0" err="1"/>
+              <a:t>quả</a:t>
+            </a:r>
+            <a:r>
+              <a:rPr dirty="0"/>
+              <a:t> </a:t>
+            </a:r>
+            <a:r>
+              <a:rPr dirty="0" err="1"/>
+              <a:t>tinh</a:t>
+            </a:r>
+            <a:r>
+              <a:rPr dirty="0"/>
+              <a:t> </a:t>
+            </a:r>
+            <a:r>
+              <a:rPr dirty="0" err="1"/>
+              <a:t>chỉnh</a:t>
+            </a:r>
+            <a:r>
+              <a:rPr dirty="0"/>
+              <a:t>: Linear Kernel </a:t>
+            </a:r>
+            <a:r>
+              <a:rPr dirty="0" err="1"/>
+              <a:t>với</a:t>
+            </a:r>
+            <a:r>
+              <a:rPr dirty="0"/>
+              <a:t> $C = 5.0$ </a:t>
+            </a:r>
+            <a:r>
+              <a:rPr dirty="0" err="1"/>
+              <a:t>cho</a:t>
+            </a:r>
+            <a:r>
+              <a:rPr dirty="0"/>
+              <a:t> </a:t>
+            </a:r>
+            <a:r>
+              <a:rPr dirty="0" err="1"/>
+              <a:t>hiệu</a:t>
+            </a:r>
+            <a:r>
+              <a:rPr dirty="0"/>
+              <a:t> </a:t>
+            </a:r>
+            <a:r>
+              <a:rPr dirty="0" err="1"/>
+              <a:t>năng</a:t>
+            </a:r>
+            <a:r>
+              <a:rPr dirty="0"/>
+              <a:t> </a:t>
+            </a:r>
+            <a:r>
+              <a:rPr dirty="0" err="1"/>
+              <a:t>rất</a:t>
+            </a:r>
+            <a:r>
+              <a:rPr dirty="0"/>
+              <a:t> </a:t>
+            </a:r>
+            <a:r>
+              <a:rPr dirty="0" err="1"/>
+              <a:t>tốt</a:t>
+            </a:r>
+            <a:r>
+              <a:rPr dirty="0"/>
+              <a:t> (5-Fold CV Score = 95.81%).</a:t>
             </a:r>
           </a:p>
         </p:txBody>
@@ -8195,7 +9483,7 @@
         <p:spPr>
           <a:xfrm>
             <a:off x="914400" y="4160520"/>
-            <a:ext cx="4846320" cy="2011680"/>
+            <a:ext cx="4846320" cy="974626"/>
           </a:xfrm>
           <a:prstGeom prst="rect">
             <a:avLst/>
@@ -8216,6 +9504,7 @@
               </a:defRPr>
             </a:pPr>
             <a:r>
+              <a:rPr dirty="0"/>
               <a:t>🥉 3. Naive Bayes (Gaussian NB)</a:t>
             </a:r>
           </a:p>
@@ -8231,15 +9520,262 @@
               </a:defRPr>
             </a:pPr>
             <a:r>
-              <a:t>• Nguyên lý: Giả định các đặc trưng độc lập khi biết lớp. Làm baseline đánh giá xác suất.</a:t>
-            </a:r>
-            <a:br/>
-            <a:r>
-              <a:t>• Siêu tham số thử nghiệm: `var_smoothing` từ $1e-9$ đến $1e-5$.</a:t>
-            </a:r>
-            <a:br/>
-            <a:r>
-              <a:t>• Kết quả tinh chỉnh: `var_smoothing = 1e-9` (5-Fold CV Score = 80.37%).</a:t>
+              <a:rPr dirty="0"/>
+              <a:t>• </a:t>
+            </a:r>
+            <a:r>
+              <a:rPr dirty="0" err="1"/>
+              <a:t>Nguyên</a:t>
+            </a:r>
+            <a:r>
+              <a:rPr dirty="0"/>
+              <a:t> </a:t>
+            </a:r>
+            <a:r>
+              <a:rPr dirty="0" err="1"/>
+              <a:t>lý</a:t>
+            </a:r>
+            <a:r>
+              <a:rPr dirty="0"/>
+              <a:t>: </a:t>
+            </a:r>
+            <a:r>
+              <a:rPr dirty="0" err="1"/>
+              <a:t>Giả</a:t>
+            </a:r>
+            <a:r>
+              <a:rPr dirty="0"/>
+              <a:t> </a:t>
+            </a:r>
+            <a:r>
+              <a:rPr dirty="0" err="1"/>
+              <a:t>định</a:t>
+            </a:r>
+            <a:r>
+              <a:rPr dirty="0"/>
+              <a:t> </a:t>
+            </a:r>
+            <a:r>
+              <a:rPr dirty="0" err="1"/>
+              <a:t>các</a:t>
+            </a:r>
+            <a:r>
+              <a:rPr dirty="0"/>
+              <a:t> </a:t>
+            </a:r>
+            <a:r>
+              <a:rPr dirty="0" err="1"/>
+              <a:t>đặc</a:t>
+            </a:r>
+            <a:r>
+              <a:rPr dirty="0"/>
+              <a:t> </a:t>
+            </a:r>
+            <a:r>
+              <a:rPr dirty="0" err="1"/>
+              <a:t>trưng</a:t>
+            </a:r>
+            <a:r>
+              <a:rPr dirty="0"/>
+              <a:t> </a:t>
+            </a:r>
+            <a:r>
+              <a:rPr dirty="0" err="1"/>
+              <a:t>độc</a:t>
+            </a:r>
+            <a:r>
+              <a:rPr dirty="0"/>
+              <a:t> </a:t>
+            </a:r>
+            <a:r>
+              <a:rPr dirty="0" err="1"/>
+              <a:t>lập</a:t>
+            </a:r>
+            <a:r>
+              <a:rPr dirty="0"/>
+              <a:t> </a:t>
+            </a:r>
+            <a:r>
+              <a:rPr dirty="0" err="1"/>
+              <a:t>khi</a:t>
+            </a:r>
+            <a:r>
+              <a:rPr dirty="0"/>
+              <a:t> </a:t>
+            </a:r>
+            <a:r>
+              <a:rPr dirty="0" err="1"/>
+              <a:t>biết</a:t>
+            </a:r>
+            <a:r>
+              <a:rPr dirty="0"/>
+              <a:t> </a:t>
+            </a:r>
+            <a:r>
+              <a:rPr dirty="0" err="1"/>
+              <a:t>lớp</a:t>
+            </a:r>
+            <a:r>
+              <a:rPr dirty="0"/>
+              <a:t>. </a:t>
+            </a:r>
+            <a:r>
+              <a:rPr dirty="0" err="1"/>
+              <a:t>Làm</a:t>
+            </a:r>
+            <a:r>
+              <a:rPr dirty="0"/>
+              <a:t> baseline </a:t>
+            </a:r>
+            <a:r>
+              <a:rPr dirty="0" err="1"/>
+              <a:t>đánh</a:t>
+            </a:r>
+            <a:r>
+              <a:rPr dirty="0"/>
+              <a:t> </a:t>
+            </a:r>
+            <a:r>
+              <a:rPr dirty="0" err="1"/>
+              <a:t>giá</a:t>
+            </a:r>
+            <a:r>
+              <a:rPr dirty="0"/>
+              <a:t> </a:t>
+            </a:r>
+            <a:r>
+              <a:rPr dirty="0" err="1"/>
+              <a:t>xác</a:t>
+            </a:r>
+            <a:r>
+              <a:rPr dirty="0"/>
+              <a:t> </a:t>
+            </a:r>
+            <a:r>
+              <a:rPr dirty="0" err="1"/>
+              <a:t>suất</a:t>
+            </a:r>
+            <a:r>
+              <a:rPr dirty="0"/>
+              <a:t>.</a:t>
+            </a:r>
+            <a:br>
+              <a:rPr dirty="0"/>
+            </a:br>
+            <a:r>
+              <a:rPr dirty="0"/>
+              <a:t>• </a:t>
+            </a:r>
+            <a:r>
+              <a:rPr dirty="0" err="1"/>
+              <a:t>Siêu</a:t>
+            </a:r>
+            <a:r>
+              <a:rPr dirty="0"/>
+              <a:t> </a:t>
+            </a:r>
+            <a:r>
+              <a:rPr dirty="0" err="1"/>
+              <a:t>tham</a:t>
+            </a:r>
+            <a:r>
+              <a:rPr dirty="0"/>
+              <a:t> </a:t>
+            </a:r>
+            <a:r>
+              <a:rPr dirty="0" err="1"/>
+              <a:t>số</a:t>
+            </a:r>
+            <a:r>
+              <a:rPr dirty="0"/>
+              <a:t> </a:t>
+            </a:r>
+            <a:r>
+              <a:rPr dirty="0" err="1"/>
+              <a:t>thử</a:t>
+            </a:r>
+            <a:r>
+              <a:rPr dirty="0"/>
+              <a:t> </a:t>
+            </a:r>
+            <a:r>
+              <a:rPr dirty="0" err="1"/>
+              <a:t>nghiệm</a:t>
+            </a:r>
+            <a:r>
+              <a:rPr dirty="0"/>
+              <a:t>: `</a:t>
+            </a:r>
+            <a:r>
+              <a:rPr dirty="0" err="1"/>
+              <a:t>var_smoothing</a:t>
+            </a:r>
+            <a:r>
+              <a:rPr dirty="0"/>
+              <a:t>` </a:t>
+            </a:r>
+            <a:r>
+              <a:rPr dirty="0" err="1"/>
+              <a:t>từ</a:t>
+            </a:r>
+            <a:r>
+              <a:rPr dirty="0"/>
+              <a:t> 1e-9 </a:t>
+            </a:r>
+            <a:r>
+              <a:rPr dirty="0" err="1"/>
+              <a:t>đến</a:t>
+            </a:r>
+            <a:r>
+              <a:rPr dirty="0"/>
+              <a:t> 1e-5.</a:t>
+            </a:r>
+            <a:br>
+              <a:rPr dirty="0"/>
+            </a:br>
+            <a:r>
+              <a:rPr dirty="0"/>
+              <a:t>• </a:t>
+            </a:r>
+            <a:r>
+              <a:rPr dirty="0" err="1"/>
+              <a:t>Kết</a:t>
+            </a:r>
+            <a:r>
+              <a:rPr dirty="0"/>
+              <a:t> </a:t>
+            </a:r>
+            <a:r>
+              <a:rPr dirty="0" err="1"/>
+              <a:t>quả</a:t>
+            </a:r>
+            <a:r>
+              <a:rPr dirty="0"/>
+              <a:t> </a:t>
+            </a:r>
+            <a:r>
+              <a:rPr dirty="0" err="1"/>
+              <a:t>tinh</a:t>
+            </a:r>
+            <a:r>
+              <a:rPr dirty="0"/>
+              <a:t> </a:t>
+            </a:r>
+            <a:r>
+              <a:rPr dirty="0" err="1"/>
+              <a:t>chỉnh</a:t>
+            </a:r>
+            <a:r>
+              <a:rPr dirty="0"/>
+              <a:t>: `</a:t>
+            </a:r>
+            <a:r>
+              <a:rPr dirty="0" err="1"/>
+              <a:t>var_smoothing</a:t>
+            </a:r>
+            <a:r>
+              <a:rPr dirty="0"/>
+              <a:t> = 1e-9` (5-Fold CV Score = 80.37%).</a:t>
             </a:r>
           </a:p>
         </p:txBody>
@@ -8299,7 +9835,7 @@
         <p:spPr>
           <a:xfrm>
             <a:off x="6400800" y="4160520"/>
-            <a:ext cx="4846320" cy="2011680"/>
+            <a:ext cx="4846320" cy="974626"/>
           </a:xfrm>
           <a:prstGeom prst="rect">
             <a:avLst/>
@@ -8320,6 +9856,7 @@
               </a:defRPr>
             </a:pPr>
             <a:r>
+              <a:rPr dirty="0"/>
               <a:t>4. K-Nearest Neighbors (KNN)</a:t>
             </a:r>
           </a:p>
@@ -8335,15 +9872,228 @@
               </a:defRPr>
             </a:pPr>
             <a:r>
-              <a:t>• Nguyên lý: Phân loại dựa trên phiếu bầu lân cận khoảng cách Euclidean.</a:t>
-            </a:r>
-            <a:br/>
-            <a:r>
-              <a:t>• Siêu tham số thử nghiệm: Số lân cận $k \in [3, 5, 7, 9, 11, 15]$, weights=('uniform', 'distance').</a:t>
-            </a:r>
-            <a:br/>
-            <a:r>
-              <a:t>• Kết quả tinh chỉnh: $k = 11$, `weights='distance'` (5-Fold CV Score = 56.06%).</a:t>
+              <a:rPr dirty="0"/>
+              <a:t>• </a:t>
+            </a:r>
+            <a:r>
+              <a:rPr dirty="0" err="1"/>
+              <a:t>Nguyên</a:t>
+            </a:r>
+            <a:r>
+              <a:rPr dirty="0"/>
+              <a:t> </a:t>
+            </a:r>
+            <a:r>
+              <a:rPr dirty="0" err="1"/>
+              <a:t>lý</a:t>
+            </a:r>
+            <a:r>
+              <a:rPr dirty="0"/>
+              <a:t>: </a:t>
+            </a:r>
+            <a:r>
+              <a:rPr dirty="0" err="1"/>
+              <a:t>Phân</a:t>
+            </a:r>
+            <a:r>
+              <a:rPr dirty="0"/>
+              <a:t> </a:t>
+            </a:r>
+            <a:r>
+              <a:rPr dirty="0" err="1"/>
+              <a:t>loại</a:t>
+            </a:r>
+            <a:r>
+              <a:rPr dirty="0"/>
+              <a:t> </a:t>
+            </a:r>
+            <a:r>
+              <a:rPr dirty="0" err="1"/>
+              <a:t>dựa</a:t>
+            </a:r>
+            <a:r>
+              <a:rPr dirty="0"/>
+              <a:t> </a:t>
+            </a:r>
+            <a:r>
+              <a:rPr dirty="0" err="1"/>
+              <a:t>trên</a:t>
+            </a:r>
+            <a:r>
+              <a:rPr dirty="0"/>
+              <a:t> </a:t>
+            </a:r>
+            <a:r>
+              <a:rPr dirty="0" err="1"/>
+              <a:t>phiếu</a:t>
+            </a:r>
+            <a:r>
+              <a:rPr dirty="0"/>
+              <a:t> </a:t>
+            </a:r>
+            <a:r>
+              <a:rPr dirty="0" err="1"/>
+              <a:t>bầu</a:t>
+            </a:r>
+            <a:r>
+              <a:rPr dirty="0"/>
+              <a:t> </a:t>
+            </a:r>
+            <a:r>
+              <a:rPr dirty="0" err="1"/>
+              <a:t>lân</a:t>
+            </a:r>
+            <a:r>
+              <a:rPr dirty="0"/>
+              <a:t> </a:t>
+            </a:r>
+            <a:r>
+              <a:rPr dirty="0" err="1"/>
+              <a:t>cận</a:t>
+            </a:r>
+            <a:r>
+              <a:rPr dirty="0"/>
+              <a:t> </a:t>
+            </a:r>
+            <a:r>
+              <a:rPr dirty="0" err="1"/>
+              <a:t>khoảng</a:t>
+            </a:r>
+            <a:r>
+              <a:rPr dirty="0"/>
+              <a:t> </a:t>
+            </a:r>
+            <a:r>
+              <a:rPr dirty="0" err="1"/>
+              <a:t>cách</a:t>
+            </a:r>
+            <a:r>
+              <a:rPr dirty="0"/>
+              <a:t> Euclidean.</a:t>
+            </a:r>
+            <a:br>
+              <a:rPr dirty="0"/>
+            </a:br>
+            <a:r>
+              <a:rPr dirty="0"/>
+              <a:t>• </a:t>
+            </a:r>
+            <a:r>
+              <a:rPr dirty="0" err="1"/>
+              <a:t>Siêu</a:t>
+            </a:r>
+            <a:r>
+              <a:rPr dirty="0"/>
+              <a:t> </a:t>
+            </a:r>
+            <a:r>
+              <a:rPr dirty="0" err="1"/>
+              <a:t>tham</a:t>
+            </a:r>
+            <a:r>
+              <a:rPr dirty="0"/>
+              <a:t> </a:t>
+            </a:r>
+            <a:r>
+              <a:rPr dirty="0" err="1"/>
+              <a:t>số</a:t>
+            </a:r>
+            <a:r>
+              <a:rPr dirty="0"/>
+              <a:t> </a:t>
+            </a:r>
+            <a:r>
+              <a:rPr dirty="0" err="1"/>
+              <a:t>thử</a:t>
+            </a:r>
+            <a:r>
+              <a:rPr dirty="0"/>
+              <a:t> </a:t>
+            </a:r>
+            <a:r>
+              <a:rPr dirty="0" err="1"/>
+              <a:t>nghiệm</a:t>
+            </a:r>
+            <a:r>
+              <a:rPr dirty="0"/>
+              <a:t>: </a:t>
+            </a:r>
+            <a:r>
+              <a:rPr dirty="0" err="1"/>
+              <a:t>Số</a:t>
+            </a:r>
+            <a:r>
+              <a:rPr dirty="0"/>
+              <a:t> </a:t>
+            </a:r>
+            <a:r>
+              <a:rPr dirty="0" err="1"/>
+              <a:t>lân</a:t>
+            </a:r>
+            <a:r>
+              <a:rPr dirty="0"/>
+              <a:t> </a:t>
+            </a:r>
+            <a:r>
+              <a:rPr dirty="0" err="1"/>
+              <a:t>cận</a:t>
+            </a:r>
+            <a:r>
+              <a:rPr dirty="0"/>
+              <a:t> k </a:t>
+            </a:r>
+            <a:r>
+              <a:rPr lang="en-US" sz="1050" dirty="0">
+                <a:solidFill>
+                  <a:srgbClr val="000000"/>
+                </a:solidFill>
+                <a:effectLst/>
+                <a:ea typeface="Times New Roman" panose="02020603050405020304" pitchFamily="18" charset="0"/>
+              </a:rPr>
+              <a:t>∈</a:t>
+            </a:r>
+            <a:r>
+              <a:rPr dirty="0"/>
+              <a:t> [3, 5, 7, 9, 11, 15], weights=('uniform', 'distance').</a:t>
+            </a:r>
+            <a:br>
+              <a:rPr dirty="0"/>
+            </a:br>
+            <a:r>
+              <a:rPr dirty="0"/>
+              <a:t>• </a:t>
+            </a:r>
+            <a:r>
+              <a:rPr dirty="0" err="1"/>
+              <a:t>Kết</a:t>
+            </a:r>
+            <a:r>
+              <a:rPr dirty="0"/>
+              <a:t> </a:t>
+            </a:r>
+            <a:r>
+              <a:rPr dirty="0" err="1"/>
+              <a:t>quả</a:t>
+            </a:r>
+            <a:r>
+              <a:rPr dirty="0"/>
+              <a:t> </a:t>
+            </a:r>
+            <a:r>
+              <a:rPr dirty="0" err="1"/>
+              <a:t>tinh</a:t>
+            </a:r>
+            <a:r>
+              <a:rPr dirty="0"/>
+              <a:t> </a:t>
+            </a:r>
+            <a:r>
+              <a:rPr dirty="0" err="1"/>
+              <a:t>chỉnh</a:t>
+            </a:r>
+            <a:r>
+              <a:rPr dirty="0"/>
+              <a:t>: k = 11, `weights='distance'` (5-Fold CV Score = 56.06%).</a:t>
             </a:r>
           </a:p>
         </p:txBody>
@@ -8576,7 +10326,13 @@
           <p:cNvGraphicFramePr>
             <a:graphicFrameLocks noGrp="1"/>
           </p:cNvGraphicFramePr>
-          <p:nvPr/>
+          <p:nvPr>
+            <p:extLst>
+              <p:ext uri="{D42A27DB-BD31-4B8C-83A1-F6EECF244321}">
+                <p14:modId xmlns:p14="http://schemas.microsoft.com/office/powerpoint/2010/main" val="1652162251"/>
+              </p:ext>
+            </p:extLst>
+          </p:nvPr>
         </p:nvGraphicFramePr>
         <p:xfrm>
           <a:off x="914400" y="2011680"/>
@@ -9053,7 +10809,8 @@
                         <a:defRPr sz="950"/>
                       </a:pPr>
                       <a:r>
-                        <a:t>Gradient Boosting</a:t>
+                        <a:rPr sz="1050"/>
+                        <a:t>Naive Bayes (Gaussian)</a:t>
                       </a:r>
                     </a:p>
                   </a:txBody>
@@ -9072,7 +10829,8 @@
                         <a:defRPr sz="950"/>
                       </a:pPr>
                       <a:r>
-                        <a:t>89.50%</a:t>
+                        <a:rPr sz="1050"/>
+                        <a:t>80.37%</a:t>
                       </a:r>
                     </a:p>
                   </a:txBody>
@@ -9091,7 +10849,8 @@
                         <a:defRPr sz="950"/>
                       </a:pPr>
                       <a:r>
-                        <a:t>100.0%</a:t>
+                        <a:rPr sz="1050"/>
+                        <a:t>81.87%</a:t>
                       </a:r>
                     </a:p>
                   </a:txBody>
@@ -9110,7 +10869,8 @@
                         <a:defRPr sz="950"/>
                       </a:pPr>
                       <a:r>
-                        <a:t>92.00%</a:t>
+                        <a:rPr sz="1050"/>
+                        <a:t>81.00%</a:t>
                       </a:r>
                     </a:p>
                   </a:txBody>
@@ -9129,7 +10889,8 @@
                         <a:defRPr sz="950"/>
                       </a:pPr>
                       <a:r>
-                        <a:t>91.98%</a:t>
+                        <a:rPr sz="1050"/>
+                        <a:t>81.05%</a:t>
                       </a:r>
                     </a:p>
                   </a:txBody>
@@ -9148,7 +10909,8 @@
                         <a:defRPr sz="950"/>
                       </a:pPr>
                       <a:r>
-                        <a:t>Overfitting</a:t>
+                        <a:rPr sz="1050"/>
+                        <a:t>Trung bình</a:t>
                       </a:r>
                     </a:p>
                   </a:txBody>
@@ -9174,7 +10936,8 @@
                         <a:defRPr sz="950"/>
                       </a:pPr>
                       <a:r>
-                        <a:t>Random Forest</a:t>
+                        <a:rPr sz="1050"/>
+                        <a:t>KNN (k=11)</a:t>
                       </a:r>
                     </a:p>
                   </a:txBody>
@@ -9193,7 +10956,8 @@
                         <a:defRPr sz="950"/>
                       </a:pPr>
                       <a:r>
-                        <a:t>87.44%</a:t>
+                        <a:rPr sz="1050" dirty="0"/>
+                        <a:t>56.06%</a:t>
                       </a:r>
                     </a:p>
                   </a:txBody>
@@ -9212,6 +10976,7 @@
                         <a:defRPr sz="950"/>
                       </a:pPr>
                       <a:r>
+                        <a:rPr sz="1050"/>
                         <a:t>100.0%</a:t>
                       </a:r>
                     </a:p>
@@ -9231,7 +10996,8 @@
                         <a:defRPr sz="950"/>
                       </a:pPr>
                       <a:r>
-                        <a:t>89.00%</a:t>
+                        <a:rPr sz="1050"/>
+                        <a:t>57.50%</a:t>
                       </a:r>
                     </a:p>
                   </a:txBody>
@@ -9250,7 +11016,8 @@
                         <a:defRPr sz="950"/>
                       </a:pPr>
                       <a:r>
-                        <a:t>88.94%</a:t>
+                        <a:rPr sz="1050"/>
+                        <a:t>57.76%</a:t>
                       </a:r>
                     </a:p>
                   </a:txBody>
@@ -9269,8 +11036,26 @@
                         <a:defRPr sz="950"/>
                       </a:pPr>
                       <a:r>
-                        <a:t>Overfitting</a:t>
+                        <a:rPr sz="1050" dirty="0" err="1"/>
+                        <a:t>Hiệu</a:t>
                       </a:r>
+                      <a:r>
+                        <a:rPr sz="1050" dirty="0"/>
+                        <a:t> </a:t>
+                      </a:r>
+                      <a:r>
+                        <a:rPr sz="1050" dirty="0" err="1"/>
+                        <a:t>năng</a:t>
+                      </a:r>
+                      <a:r>
+                        <a:rPr sz="1050" dirty="0"/>
+                        <a:t> </a:t>
+                      </a:r>
+                      <a:r>
+                        <a:rPr sz="1050" dirty="0" err="1"/>
+                        <a:t>kém</a:t>
+                      </a:r>
+                      <a:endParaRPr sz="1050" dirty="0"/>
                     </a:p>
                   </a:txBody>
                   <a:tcPr>
@@ -9294,9 +11079,7 @@
                       <a:pPr algn="l">
                         <a:defRPr sz="950"/>
                       </a:pPr>
-                      <a:r>
-                        <a:t>Naive Bayes (Gaussian)</a:t>
-                      </a:r>
+                      <a:endParaRPr dirty="0"/>
                     </a:p>
                   </a:txBody>
                   <a:tcPr>
@@ -9313,9 +11096,7 @@
                       <a:pPr algn="ctr">
                         <a:defRPr sz="950"/>
                       </a:pPr>
-                      <a:r>
-                        <a:t>80.37%</a:t>
-                      </a:r>
+                      <a:endParaRPr dirty="0"/>
                     </a:p>
                   </a:txBody>
                   <a:tcPr>
@@ -9332,9 +11113,7 @@
                       <a:pPr algn="ctr">
                         <a:defRPr sz="950"/>
                       </a:pPr>
-                      <a:r>
-                        <a:t>81.87%</a:t>
-                      </a:r>
+                      <a:endParaRPr/>
                     </a:p>
                   </a:txBody>
                   <a:tcPr>
@@ -9351,9 +11130,7 @@
                       <a:pPr algn="ctr">
                         <a:defRPr sz="950"/>
                       </a:pPr>
-                      <a:r>
-                        <a:t>81.00%</a:t>
-                      </a:r>
+                      <a:endParaRPr/>
                     </a:p>
                   </a:txBody>
                   <a:tcPr>
@@ -9370,9 +11147,7 @@
                       <a:pPr algn="ctr">
                         <a:defRPr sz="950"/>
                       </a:pPr>
-                      <a:r>
-                        <a:t>81.05%</a:t>
-                      </a:r>
+                      <a:endParaRPr/>
                     </a:p>
                   </a:txBody>
                   <a:tcPr>
@@ -9389,9 +11164,7 @@
                       <a:pPr algn="ctr">
                         <a:defRPr sz="950"/>
                       </a:pPr>
-                      <a:r>
-                        <a:t>Trung bình</a:t>
-                      </a:r>
+                      <a:endParaRPr/>
                     </a:p>
                   </a:txBody>
                   <a:tcPr>
@@ -9415,9 +11188,7 @@
                       <a:pPr algn="l">
                         <a:defRPr sz="950"/>
                       </a:pPr>
-                      <a:r>
-                        <a:t>KNN (k=11)</a:t>
-                      </a:r>
+                      <a:endParaRPr/>
                     </a:p>
                   </a:txBody>
                   <a:tcPr>
@@ -9434,9 +11205,7 @@
                       <a:pPr algn="ctr">
                         <a:defRPr sz="950"/>
                       </a:pPr>
-                      <a:r>
-                        <a:t>56.06%</a:t>
-                      </a:r>
+                      <a:endParaRPr/>
                     </a:p>
                   </a:txBody>
                   <a:tcPr>
@@ -9453,9 +11222,7 @@
                       <a:pPr algn="ctr">
                         <a:defRPr sz="950"/>
                       </a:pPr>
-                      <a:r>
-                        <a:t>100.0%</a:t>
-                      </a:r>
+                      <a:endParaRPr/>
                     </a:p>
                   </a:txBody>
                   <a:tcPr>
@@ -9472,9 +11239,7 @@
                       <a:pPr algn="ctr">
                         <a:defRPr sz="950"/>
                       </a:pPr>
-                      <a:r>
-                        <a:t>57.50%</a:t>
-                      </a:r>
+                      <a:endParaRPr/>
                     </a:p>
                   </a:txBody>
                   <a:tcPr>
@@ -9491,9 +11256,7 @@
                       <a:pPr algn="ctr">
                         <a:defRPr sz="950"/>
                       </a:pPr>
-                      <a:r>
-                        <a:t>57.76%</a:t>
-                      </a:r>
+                      <a:endParaRPr/>
                     </a:p>
                   </a:txBody>
                   <a:tcPr>
@@ -9510,9 +11273,7 @@
                       <a:pPr algn="ctr">
                         <a:defRPr sz="950"/>
                       </a:pPr>
-                      <a:r>
-                        <a:t>Hiệu năng kém</a:t>
-                      </a:r>
+                      <a:endParaRPr dirty="0"/>
                     </a:p>
                   </a:txBody>
                   <a:tcPr>
@@ -9609,7 +11370,7 @@
         </p:nvSpPr>
         <p:spPr>
           <a:xfrm>
-            <a:off x="7863840" y="4663440"/>
+            <a:off x="7863840" y="4686300"/>
             <a:ext cx="3474720" cy="2194560"/>
           </a:xfrm>
           <a:prstGeom prst="rect">

</xml_diff>